<commit_message>
adj slide and pdf
</commit_message>
<xml_diff>
--- a/B5-T1_presentacion.pptx
+++ b/B5-T1_presentacion.pptx
@@ -15,9 +15,9 @@
     <p:sldId id="260" r:id="rId10"/>
     <p:sldId id="261" r:id="rId11"/>
     <p:sldId id="262" r:id="rId12"/>
+    <p:sldId id="270" r:id="rId20"/>
     <p:sldId id="263" r:id="rId13"/>
     <p:sldId id="264" r:id="rId14"/>
-    <p:sldId id="265" r:id="rId15"/>
     <p:sldId id="266" r:id="rId16"/>
     <p:sldId id="267" r:id="rId17"/>
     <p:sldId id="268" r:id="rId18"/>
@@ -1533,163 +1533,6 @@
       <p:sp>
         <p:nvSpPr>
           <p:cNvPr id="15" name="Google Shape;15;p1:notes"/>
-          <p:cNvSpPr txBox="1"/>
-          <p:nvPr>
-            <p:ph idx="12" type="sldNum"/>
-          </p:nvPr>
-        </p:nvSpPr>
-        <p:spPr>
-          <a:xfrm>
-            <a:off x="3884613" y="8685213"/>
-            <a:ext cx="2971800" cy="458787"/>
-          </a:xfrm>
-          <a:prstGeom prst="rect">
-            <a:avLst/>
-          </a:prstGeom>
-          <a:noFill/>
-          <a:ln>
-            <a:noFill/>
-          </a:ln>
-        </p:spPr>
-        <p:txBody>
-          <a:bodyPr anchorCtr="0" anchor="b" bIns="45700" lIns="91425" spcFirstLastPara="1" rIns="91425" wrap="square" tIns="45700">
-            <a:noAutofit/>
-          </a:bodyPr>
-          <a:lstStyle/>
-          <a:p>
-            <a:pPr indent="0" lvl="0" marL="0" rtl="0" algn="r">
-              <a:spcBef>
-                <a:spcPts val="0"/>
-              </a:spcBef>
-              <a:spcAft>
-                <a:spcPts val="0"/>
-              </a:spcAft>
-              <a:buNone/>
-            </a:pPr>
-            <a:fld id="{00000000-1234-1234-1234-123412341234}" type="slidenum">
-              <a:rPr lang="en-US"/>
-              <a:t>‹#›</a:t>
-            </a:fld>
-            <a:endParaRPr/>
-          </a:p>
-        </p:txBody>
-      </p:sp>
-    </p:spTree>
-  </p:cSld>
-  <p:clrMapOvr>
-    <a:masterClrMapping/>
-  </p:clrMapOvr>
-</p:notes>
-</file>
-
-<file path=ppt/notesSlides/notesSlide10.xml><?xml version="1.0" encoding="utf-8"?>
-<p:notes xmlns:a="http://schemas.openxmlformats.org/drawingml/2006/main" xmlns:r="http://schemas.openxmlformats.org/officeDocument/2006/relationships" xmlns:mc="http://schemas.openxmlformats.org/markup-compatibility/2006" xmlns:mv="urn:schemas-microsoft-com:mac:vml" xmlns:p="http://schemas.openxmlformats.org/presentationml/2006/main" xmlns:c="http://schemas.openxmlformats.org/drawingml/2006/chart" xmlns:dgm="http://schemas.openxmlformats.org/drawingml/2006/diagram" xmlns:o="urn:schemas-microsoft-com:office:office" xmlns:v="urn:schemas-microsoft-com:vml" xmlns:pvml="urn:schemas-microsoft-com:office:powerpoint" xmlns:com="http://schemas.openxmlformats.org/drawingml/2006/compatibility" xmlns:p14="http://schemas.microsoft.com/office/powerpoint/2010/main" xmlns:p15="http://schemas.microsoft.com/office/powerpoint/2012/main" xmlns:ahyp="http://schemas.microsoft.com/office/drawing/2018/hyperlinkcolor" showMasterPhAnim="0" showMasterSp="0">
-  <p:cSld>
-    <p:spTree>
-      <p:nvGrpSpPr>
-        <p:cNvPr id="218" name="Shape 218"/>
-        <p:cNvGrpSpPr/>
-        <p:nvPr/>
-      </p:nvGrpSpPr>
-      <p:grpSpPr>
-        <a:xfrm>
-          <a:off x="0" y="0"/>
-          <a:ext cx="0" cy="0"/>
-          <a:chOff x="0" y="0"/>
-          <a:chExt cx="0" cy="0"/>
-        </a:xfrm>
-      </p:grpSpPr>
-      <p:sp>
-        <p:nvSpPr>
-          <p:cNvPr id="219" name="Google Shape;219;p10:notes"/>
-          <p:cNvSpPr/>
-          <p:nvPr>
-            <p:ph idx="2" type="sldImg"/>
-          </p:nvPr>
-        </p:nvSpPr>
-        <p:spPr>
-          <a:xfrm>
-            <a:off x="685800" y="1143000"/>
-            <a:ext cx="5486400" cy="3086100"/>
-          </a:xfrm>
-          <a:custGeom>
-            <a:rect b="b" l="l" r="r" t="t"/>
-            <a:pathLst>
-              <a:path extrusionOk="0" h="120000" w="120000">
-                <a:moveTo>
-                  <a:pt x="0" y="0"/>
-                </a:moveTo>
-                <a:lnTo>
-                  <a:pt x="120000" y="0"/>
-                </a:lnTo>
-                <a:lnTo>
-                  <a:pt x="120000" y="120000"/>
-                </a:lnTo>
-                <a:lnTo>
-                  <a:pt x="0" y="120000"/>
-                </a:lnTo>
-                <a:close/>
-              </a:path>
-            </a:pathLst>
-          </a:custGeom>
-          <a:noFill/>
-          <a:ln cap="flat" cmpd="sng" w="12700">
-            <a:solidFill>
-              <a:srgbClr val="000000"/>
-            </a:solidFill>
-            <a:prstDash val="solid"/>
-            <a:round/>
-            <a:headEnd len="sm" w="sm" type="none"/>
-            <a:tailEnd len="sm" w="sm" type="none"/>
-          </a:ln>
-        </p:spPr>
-      </p:sp>
-      <p:sp>
-        <p:nvSpPr>
-          <p:cNvPr id="220" name="Google Shape;220;p10:notes"/>
-          <p:cNvSpPr txBox="1"/>
-          <p:nvPr>
-            <p:ph idx="1" type="body"/>
-          </p:nvPr>
-        </p:nvSpPr>
-        <p:spPr>
-          <a:xfrm>
-            <a:off x="685800" y="4400550"/>
-            <a:ext cx="5486400" cy="3600450"/>
-          </a:xfrm>
-          <a:prstGeom prst="rect">
-            <a:avLst/>
-          </a:prstGeom>
-          <a:noFill/>
-          <a:ln>
-            <a:noFill/>
-          </a:ln>
-        </p:spPr>
-        <p:txBody>
-          <a:bodyPr anchorCtr="0" anchor="t" bIns="45700" lIns="91425" spcFirstLastPara="1" rIns="91425" wrap="square" tIns="45700">
-            <a:noAutofit/>
-          </a:bodyPr>
-          <a:lstStyle/>
-          <a:p>
-            <a:pPr indent="0" lvl="0" marL="0" rtl="0" algn="l">
-              <a:spcBef>
-                <a:spcPts val="0"/>
-              </a:spcBef>
-              <a:spcAft>
-                <a:spcPts val="0"/>
-              </a:spcAft>
-              <a:buNone/>
-            </a:pPr>
-            <a:r>
-              <a:t/>
-            </a:r>
-            <a:endParaRPr/>
-          </a:p>
-        </p:txBody>
-      </p:sp>
-      <p:sp>
-        <p:nvSpPr>
-          <p:cNvPr id="221" name="Google Shape;221;p10:notes"/>
           <p:cNvSpPr txBox="1"/>
           <p:nvPr>
             <p:ph idx="12" type="sldNum"/>
@@ -5079,1022 +4922,6 @@
 </p:sld>
 </file>
 
-<file path=ppt/slides/slide10.xml><?xml version="1.0" encoding="utf-8"?>
-<p:sld xmlns:a="http://schemas.openxmlformats.org/drawingml/2006/main" xmlns:r="http://schemas.openxmlformats.org/officeDocument/2006/relationships" xmlns:mc="http://schemas.openxmlformats.org/markup-compatibility/2006" xmlns:mv="urn:schemas-microsoft-com:mac:vml" xmlns:p="http://schemas.openxmlformats.org/presentationml/2006/main" xmlns:c="http://schemas.openxmlformats.org/drawingml/2006/chart" xmlns:dgm="http://schemas.openxmlformats.org/drawingml/2006/diagram" xmlns:o="urn:schemas-microsoft-com:office:office" xmlns:v="urn:schemas-microsoft-com:vml" xmlns:pvml="urn:schemas-microsoft-com:office:powerpoint" xmlns:com="http://schemas.openxmlformats.org/drawingml/2006/compatibility" xmlns:p14="http://schemas.microsoft.com/office/powerpoint/2010/main" xmlns:p15="http://schemas.microsoft.com/office/powerpoint/2012/main" xmlns:ahyp="http://schemas.microsoft.com/office/drawing/2018/hyperlinkcolor">
-  <p:cSld>
-    <p:bg>
-      <p:bgPr>
-        <a:solidFill>
-          <a:srgbClr val="0B2545"/>
-        </a:solidFill>
-      </p:bgPr>
-    </p:bg>
-    <p:spTree>
-      <p:nvGrpSpPr>
-        <p:cNvPr id="222" name="Shape 222"/>
-        <p:cNvGrpSpPr/>
-        <p:nvPr/>
-      </p:nvGrpSpPr>
-      <p:grpSpPr>
-        <a:xfrm>
-          <a:off x="0" y="0"/>
-          <a:ext cx="0" cy="0"/>
-          <a:chOff x="0" y="0"/>
-          <a:chExt cx="0" cy="0"/>
-        </a:xfrm>
-      </p:grpSpPr>
-      <p:sp>
-        <p:nvSpPr>
-          <p:cNvPr id="223" name="Google Shape;223;p13"/>
-          <p:cNvSpPr txBox="1"/>
-          <p:nvPr/>
-        </p:nvSpPr>
-        <p:spPr>
-          <a:xfrm>
-            <a:off x="640080" y="457200"/>
-            <a:ext cx="7315200" cy="320040"/>
-          </a:xfrm>
-          <a:prstGeom prst="rect">
-            <a:avLst/>
-          </a:prstGeom>
-          <a:noFill/>
-          <a:ln>
-            <a:noFill/>
-          </a:ln>
-        </p:spPr>
-        <p:txBody>
-          <a:bodyPr anchorCtr="0" anchor="ctr" bIns="0" lIns="0" spcFirstLastPara="1" rIns="0" wrap="square" tIns="0">
-            <a:noAutofit/>
-          </a:bodyPr>
-          <a:lstStyle/>
-          <a:p>
-            <a:pPr indent="0" lvl="0" marL="0" marR="0" rtl="0" algn="l">
-              <a:spcBef>
-                <a:spcPts val="0"/>
-              </a:spcBef>
-              <a:spcAft>
-                <a:spcPts val="0"/>
-              </a:spcAft>
-              <a:buClr>
-                <a:srgbClr val="8DA9C4"/>
-              </a:buClr>
-              <a:buSzPts val="1300"/>
-              <a:buFont typeface="Calibri"/>
-              <a:buNone/>
-            </a:pPr>
-            <a:r>
-              <a:rPr b="1" i="0" lang="en-US" sz="1300" u="none" cap="none" strike="noStrike">
-                <a:solidFill>
-                  <a:srgbClr val="8DA9C4"/>
-                </a:solidFill>
-                <a:latin typeface="Calibri"/>
-                <a:ea typeface="Calibri"/>
-                <a:cs typeface="Calibri"/>
-                <a:sym typeface="Calibri"/>
-              </a:rPr>
-              <a:t>CONTRASTE ESTADÍSTICO</a:t>
-            </a:r>
-            <a:endParaRPr b="0" i="0" sz="1300" u="none" cap="none" strike="noStrike">
-              <a:solidFill>
-                <a:schemeClr val="dk1"/>
-              </a:solidFill>
-              <a:latin typeface="Calibri"/>
-              <a:ea typeface="Calibri"/>
-              <a:cs typeface="Calibri"/>
-              <a:sym typeface="Calibri"/>
-            </a:endParaRPr>
-          </a:p>
-        </p:txBody>
-      </p:sp>
-      <p:sp>
-        <p:nvSpPr>
-          <p:cNvPr id="224" name="Google Shape;224;p13"/>
-          <p:cNvSpPr txBox="1"/>
-          <p:nvPr/>
-        </p:nvSpPr>
-        <p:spPr>
-          <a:xfrm>
-            <a:off x="640080" y="749808"/>
-            <a:ext cx="10881360" cy="822960"/>
-          </a:xfrm>
-          <a:prstGeom prst="rect">
-            <a:avLst/>
-          </a:prstGeom>
-          <a:noFill/>
-          <a:ln>
-            <a:noFill/>
-          </a:ln>
-        </p:spPr>
-        <p:txBody>
-          <a:bodyPr anchorCtr="0" anchor="ctr" bIns="0" lIns="0" spcFirstLastPara="1" rIns="0" wrap="square" tIns="0">
-            <a:noAutofit/>
-          </a:bodyPr>
-          <a:lstStyle/>
-          <a:p>
-            <a:pPr indent="0" lvl="0" marL="0" marR="0" rtl="0" algn="l">
-              <a:spcBef>
-                <a:spcPts val="0"/>
-              </a:spcBef>
-              <a:spcAft>
-                <a:spcPts val="0"/>
-              </a:spcAft>
-              <a:buClr>
-                <a:srgbClr val="FFFFFF"/>
-              </a:buClr>
-              <a:buSzPts val="3200"/>
-              <a:buFont typeface="Cambria"/>
-              <a:buNone/>
-            </a:pPr>
-            <a:r>
-              <a:rPr b="1" i="0" lang="en-US" sz="3200" u="none" cap="none" strike="noStrike">
-                <a:solidFill>
-                  <a:srgbClr val="FFFFFF"/>
-                </a:solidFill>
-                <a:latin typeface="Cambria"/>
-                <a:ea typeface="Cambria"/>
-                <a:cs typeface="Cambria"/>
-                <a:sym typeface="Cambria"/>
-              </a:rPr>
-              <a:t>¿Alguna de esas subidas resiste el contraste?</a:t>
-            </a:r>
-            <a:endParaRPr b="0" i="0" sz="3200" u="none" cap="none" strike="noStrike">
-              <a:solidFill>
-                <a:schemeClr val="dk1"/>
-              </a:solidFill>
-              <a:latin typeface="Calibri"/>
-              <a:ea typeface="Calibri"/>
-              <a:cs typeface="Calibri"/>
-              <a:sym typeface="Calibri"/>
-            </a:endParaRPr>
-          </a:p>
-        </p:txBody>
-      </p:sp>
-      <p:sp>
-        <p:nvSpPr>
-          <p:cNvPr id="225" name="Google Shape;225;p13"/>
-          <p:cNvSpPr txBox="1"/>
-          <p:nvPr/>
-        </p:nvSpPr>
-        <p:spPr>
-          <a:xfrm>
-            <a:off x="822960" y="1828800"/>
-            <a:ext cx="3383280" cy="1463040"/>
-          </a:xfrm>
-          <a:prstGeom prst="rect">
-            <a:avLst/>
-          </a:prstGeom>
-          <a:noFill/>
-          <a:ln>
-            <a:noFill/>
-          </a:ln>
-        </p:spPr>
-        <p:txBody>
-          <a:bodyPr anchorCtr="0" anchor="ctr" bIns="0" lIns="0" spcFirstLastPara="1" rIns="0" wrap="square" tIns="0">
-            <a:noAutofit/>
-          </a:bodyPr>
-          <a:lstStyle/>
-          <a:p>
-            <a:pPr indent="0" lvl="0" marL="0" marR="0" rtl="0" algn="ctr">
-              <a:spcBef>
-                <a:spcPts val="0"/>
-              </a:spcBef>
-              <a:spcAft>
-                <a:spcPts val="0"/>
-              </a:spcAft>
-              <a:buClr>
-                <a:srgbClr val="8DA9C4"/>
-              </a:buClr>
-              <a:buSzPts val="8200"/>
-              <a:buFont typeface="Cambria"/>
-              <a:buNone/>
-            </a:pPr>
-            <a:r>
-              <a:rPr b="1" i="0" lang="en-US" sz="8200" u="none" cap="none" strike="noStrike">
-                <a:solidFill>
-                  <a:srgbClr val="8DA9C4"/>
-                </a:solidFill>
-                <a:latin typeface="Cambria"/>
-                <a:ea typeface="Cambria"/>
-                <a:cs typeface="Cambria"/>
-                <a:sym typeface="Cambria"/>
-              </a:rPr>
-              <a:t>20</a:t>
-            </a:r>
-            <a:endParaRPr b="0" i="0" sz="8200" u="none" cap="none" strike="noStrike">
-              <a:solidFill>
-                <a:schemeClr val="dk1"/>
-              </a:solidFill>
-              <a:latin typeface="Calibri"/>
-              <a:ea typeface="Calibri"/>
-              <a:cs typeface="Calibri"/>
-              <a:sym typeface="Calibri"/>
-            </a:endParaRPr>
-          </a:p>
-        </p:txBody>
-      </p:sp>
-      <p:sp>
-        <p:nvSpPr>
-          <p:cNvPr id="226" name="Google Shape;226;p13"/>
-          <p:cNvSpPr txBox="1"/>
-          <p:nvPr/>
-        </p:nvSpPr>
-        <p:spPr>
-          <a:xfrm>
-            <a:off x="822960" y="3246120"/>
-            <a:ext cx="3383280" cy="640080"/>
-          </a:xfrm>
-          <a:prstGeom prst="rect">
-            <a:avLst/>
-          </a:prstGeom>
-          <a:noFill/>
-          <a:ln>
-            <a:noFill/>
-          </a:ln>
-        </p:spPr>
-        <p:txBody>
-          <a:bodyPr anchorCtr="0" anchor="ctr" bIns="0" lIns="0" spcFirstLastPara="1" rIns="0" wrap="square" tIns="0">
-            <a:noAutofit/>
-          </a:bodyPr>
-          <a:lstStyle/>
-          <a:p>
-            <a:pPr indent="0" lvl="0" marL="0" marR="0" rtl="0" algn="ctr">
-              <a:spcBef>
-                <a:spcPts val="0"/>
-              </a:spcBef>
-              <a:spcAft>
-                <a:spcPts val="0"/>
-              </a:spcAft>
-              <a:buClr>
-                <a:srgbClr val="8DA9C4"/>
-              </a:buClr>
-              <a:buSzPts val="1400"/>
-              <a:buFont typeface="Calibri"/>
-              <a:buNone/>
-            </a:pPr>
-            <a:r>
-              <a:rPr b="0" i="0" lang="en-US" sz="1400" u="none" cap="none" strike="noStrike">
-                <a:solidFill>
-                  <a:srgbClr val="8DA9C4"/>
-                </a:solidFill>
-                <a:latin typeface="Calibri"/>
-                <a:ea typeface="Calibri"/>
-                <a:cs typeface="Calibri"/>
-                <a:sym typeface="Calibri"/>
-              </a:rPr>
-              <a:t>configuraciones</a:t>
-            </a:r>
-            <a:endParaRPr b="0" i="0" sz="1400" u="none" cap="none" strike="noStrike">
-              <a:solidFill>
-                <a:schemeClr val="dk1"/>
-              </a:solidFill>
-              <a:latin typeface="Calibri"/>
-              <a:ea typeface="Calibri"/>
-              <a:cs typeface="Calibri"/>
-              <a:sym typeface="Calibri"/>
-            </a:endParaRPr>
-          </a:p>
-          <a:p>
-            <a:pPr indent="0" lvl="0" marL="0" marR="0" rtl="0" algn="ctr">
-              <a:spcBef>
-                <a:spcPts val="0"/>
-              </a:spcBef>
-              <a:spcAft>
-                <a:spcPts val="0"/>
-              </a:spcAft>
-              <a:buClr>
-                <a:srgbClr val="8DA9C4"/>
-              </a:buClr>
-              <a:buSzPts val="1400"/>
-              <a:buFont typeface="Calibri"/>
-              <a:buNone/>
-            </a:pPr>
-            <a:r>
-              <a:rPr b="0" i="0" lang="en-US" sz="1400" u="none" cap="none" strike="noStrike">
-                <a:solidFill>
-                  <a:srgbClr val="8DA9C4"/>
-                </a:solidFill>
-                <a:latin typeface="Calibri"/>
-                <a:ea typeface="Calibri"/>
-                <a:cs typeface="Calibri"/>
-                <a:sym typeface="Calibri"/>
-              </a:rPr>
-              <a:t>contrastadas</a:t>
-            </a:r>
-            <a:endParaRPr b="0" i="0" sz="1400" u="none" cap="none" strike="noStrike">
-              <a:solidFill>
-                <a:schemeClr val="dk1"/>
-              </a:solidFill>
-              <a:latin typeface="Calibri"/>
-              <a:ea typeface="Calibri"/>
-              <a:cs typeface="Calibri"/>
-              <a:sym typeface="Calibri"/>
-            </a:endParaRPr>
-          </a:p>
-        </p:txBody>
-      </p:sp>
-      <p:sp>
-        <p:nvSpPr>
-          <p:cNvPr id="227" name="Google Shape;227;p13"/>
-          <p:cNvSpPr txBox="1"/>
-          <p:nvPr/>
-        </p:nvSpPr>
-        <p:spPr>
-          <a:xfrm>
-            <a:off x="4343400" y="1828800"/>
-            <a:ext cx="3383280" cy="1463040"/>
-          </a:xfrm>
-          <a:prstGeom prst="rect">
-            <a:avLst/>
-          </a:prstGeom>
-          <a:noFill/>
-          <a:ln>
-            <a:noFill/>
-          </a:ln>
-        </p:spPr>
-        <p:txBody>
-          <a:bodyPr anchorCtr="0" anchor="ctr" bIns="0" lIns="0" spcFirstLastPara="1" rIns="0" wrap="square" tIns="0">
-            <a:noAutofit/>
-          </a:bodyPr>
-          <a:lstStyle/>
-          <a:p>
-            <a:pPr indent="0" lvl="0" marL="0" marR="0" rtl="0" algn="ctr">
-              <a:spcBef>
-                <a:spcPts val="0"/>
-              </a:spcBef>
-              <a:spcAft>
-                <a:spcPts val="0"/>
-              </a:spcAft>
-              <a:buClr>
-                <a:srgbClr val="D64550"/>
-              </a:buClr>
-              <a:buSzPts val="8200"/>
-              <a:buFont typeface="Cambria"/>
-              <a:buNone/>
-            </a:pPr>
-            <a:r>
-              <a:rPr b="1" i="0" lang="en-US" sz="8200" u="none" cap="none" strike="noStrike">
-                <a:solidFill>
-                  <a:srgbClr val="D64550"/>
-                </a:solidFill>
-                <a:latin typeface="Cambria"/>
-                <a:ea typeface="Cambria"/>
-                <a:cs typeface="Cambria"/>
-                <a:sym typeface="Cambria"/>
-              </a:rPr>
-              <a:t>0</a:t>
-            </a:r>
-            <a:endParaRPr b="0" i="0" sz="8200" u="none" cap="none" strike="noStrike">
-              <a:solidFill>
-                <a:schemeClr val="dk1"/>
-              </a:solidFill>
-              <a:latin typeface="Calibri"/>
-              <a:ea typeface="Calibri"/>
-              <a:cs typeface="Calibri"/>
-              <a:sym typeface="Calibri"/>
-            </a:endParaRPr>
-          </a:p>
-        </p:txBody>
-      </p:sp>
-      <p:sp>
-        <p:nvSpPr>
-          <p:cNvPr id="228" name="Google Shape;228;p13"/>
-          <p:cNvSpPr txBox="1"/>
-          <p:nvPr/>
-        </p:nvSpPr>
-        <p:spPr>
-          <a:xfrm>
-            <a:off x="4343400" y="3246120"/>
-            <a:ext cx="3383280" cy="640080"/>
-          </a:xfrm>
-          <a:prstGeom prst="rect">
-            <a:avLst/>
-          </a:prstGeom>
-          <a:noFill/>
-          <a:ln>
-            <a:noFill/>
-          </a:ln>
-        </p:spPr>
-        <p:txBody>
-          <a:bodyPr anchorCtr="0" anchor="ctr" bIns="0" lIns="0" spcFirstLastPara="1" rIns="0" wrap="square" tIns="0">
-            <a:noAutofit/>
-          </a:bodyPr>
-          <a:lstStyle/>
-          <a:p>
-            <a:pPr indent="0" lvl="0" marL="0" marR="0" rtl="0" algn="ctr">
-              <a:spcBef>
-                <a:spcPts val="0"/>
-              </a:spcBef>
-              <a:spcAft>
-                <a:spcPts val="0"/>
-              </a:spcAft>
-              <a:buClr>
-                <a:srgbClr val="8DA9C4"/>
-              </a:buClr>
-              <a:buSzPts val="1400"/>
-              <a:buFont typeface="Calibri"/>
-              <a:buNone/>
-            </a:pPr>
-            <a:r>
-              <a:rPr b="0" i="0" lang="en-US" sz="1400" u="none" cap="none" strike="noStrike">
-                <a:solidFill>
-                  <a:srgbClr val="8DA9C4"/>
-                </a:solidFill>
-                <a:latin typeface="Calibri"/>
-                <a:ea typeface="Calibri"/>
-                <a:cs typeface="Calibri"/>
-                <a:sym typeface="Calibri"/>
-              </a:rPr>
-              <a:t>mejoras</a:t>
-            </a:r>
-            <a:endParaRPr b="0" i="0" sz="1400" u="none" cap="none" strike="noStrike">
-              <a:solidFill>
-                <a:schemeClr val="dk1"/>
-              </a:solidFill>
-              <a:latin typeface="Calibri"/>
-              <a:ea typeface="Calibri"/>
-              <a:cs typeface="Calibri"/>
-              <a:sym typeface="Calibri"/>
-            </a:endParaRPr>
-          </a:p>
-          <a:p>
-            <a:pPr indent="0" lvl="0" marL="0" marR="0" rtl="0" algn="ctr">
-              <a:spcBef>
-                <a:spcPts val="0"/>
-              </a:spcBef>
-              <a:spcAft>
-                <a:spcPts val="0"/>
-              </a:spcAft>
-              <a:buClr>
-                <a:srgbClr val="8DA9C4"/>
-              </a:buClr>
-              <a:buSzPts val="1400"/>
-              <a:buFont typeface="Calibri"/>
-              <a:buNone/>
-            </a:pPr>
-            <a:r>
-              <a:rPr b="0" i="0" lang="en-US" sz="1400" u="none" cap="none" strike="noStrike">
-                <a:solidFill>
-                  <a:srgbClr val="8DA9C4"/>
-                </a:solidFill>
-                <a:latin typeface="Calibri"/>
-                <a:ea typeface="Calibri"/>
-                <a:cs typeface="Calibri"/>
-                <a:sym typeface="Calibri"/>
-              </a:rPr>
-              <a:t>significativas</a:t>
-            </a:r>
-            <a:endParaRPr b="0" i="0" sz="1400" u="none" cap="none" strike="noStrike">
-              <a:solidFill>
-                <a:schemeClr val="dk1"/>
-              </a:solidFill>
-              <a:latin typeface="Calibri"/>
-              <a:ea typeface="Calibri"/>
-              <a:cs typeface="Calibri"/>
-              <a:sym typeface="Calibri"/>
-            </a:endParaRPr>
-          </a:p>
-        </p:txBody>
-      </p:sp>
-      <p:sp>
-        <p:nvSpPr>
-          <p:cNvPr id="229" name="Google Shape;229;p13"/>
-          <p:cNvSpPr txBox="1"/>
-          <p:nvPr/>
-        </p:nvSpPr>
-        <p:spPr>
-          <a:xfrm>
-            <a:off x="7863840" y="1828800"/>
-            <a:ext cx="3383280" cy="1463040"/>
-          </a:xfrm>
-          <a:prstGeom prst="rect">
-            <a:avLst/>
-          </a:prstGeom>
-          <a:noFill/>
-          <a:ln>
-            <a:noFill/>
-          </a:ln>
-        </p:spPr>
-        <p:txBody>
-          <a:bodyPr anchorCtr="0" anchor="ctr" bIns="0" lIns="0" spcFirstLastPara="1" rIns="0" wrap="square" tIns="0">
-            <a:noAutofit/>
-          </a:bodyPr>
-          <a:lstStyle/>
-          <a:p>
-            <a:pPr indent="0" lvl="0" marL="0" marR="0" rtl="0" algn="ctr">
-              <a:spcBef>
-                <a:spcPts val="0"/>
-              </a:spcBef>
-              <a:spcAft>
-                <a:spcPts val="0"/>
-              </a:spcAft>
-              <a:buClr>
-                <a:srgbClr val="F2A0A6"/>
-              </a:buClr>
-              <a:buSzPts val="8200"/>
-              <a:buFont typeface="Cambria"/>
-              <a:buNone/>
-            </a:pPr>
-            <a:r>
-              <a:rPr b="1" i="0" lang="en-US" sz="8200" u="none" cap="none" strike="noStrike">
-                <a:solidFill>
-                  <a:srgbClr val="F2A0A6"/>
-                </a:solidFill>
-                <a:latin typeface="Cambria"/>
-                <a:ea typeface="Cambria"/>
-                <a:cs typeface="Cambria"/>
-                <a:sym typeface="Cambria"/>
-              </a:rPr>
-              <a:t>6</a:t>
-            </a:r>
-            <a:endParaRPr b="0" i="0" sz="8200" u="none" cap="none" strike="noStrike">
-              <a:solidFill>
-                <a:schemeClr val="dk1"/>
-              </a:solidFill>
-              <a:latin typeface="Calibri"/>
-              <a:ea typeface="Calibri"/>
-              <a:cs typeface="Calibri"/>
-              <a:sym typeface="Calibri"/>
-            </a:endParaRPr>
-          </a:p>
-        </p:txBody>
-      </p:sp>
-      <p:sp>
-        <p:nvSpPr>
-          <p:cNvPr id="230" name="Google Shape;230;p13"/>
-          <p:cNvSpPr txBox="1"/>
-          <p:nvPr/>
-        </p:nvSpPr>
-        <p:spPr>
-          <a:xfrm>
-            <a:off x="7863840" y="3246120"/>
-            <a:ext cx="3383280" cy="640080"/>
-          </a:xfrm>
-          <a:prstGeom prst="rect">
-            <a:avLst/>
-          </a:prstGeom>
-          <a:noFill/>
-          <a:ln>
-            <a:noFill/>
-          </a:ln>
-        </p:spPr>
-        <p:txBody>
-          <a:bodyPr anchorCtr="0" anchor="ctr" bIns="0" lIns="0" spcFirstLastPara="1" rIns="0" wrap="square" tIns="0">
-            <a:noAutofit/>
-          </a:bodyPr>
-          <a:lstStyle/>
-          <a:p>
-            <a:pPr indent="0" lvl="0" marL="0" marR="0" rtl="0" algn="ctr">
-              <a:spcBef>
-                <a:spcPts val="0"/>
-              </a:spcBef>
-              <a:spcAft>
-                <a:spcPts val="0"/>
-              </a:spcAft>
-              <a:buClr>
-                <a:srgbClr val="8DA9C4"/>
-              </a:buClr>
-              <a:buSzPts val="1400"/>
-              <a:buFont typeface="Calibri"/>
-              <a:buNone/>
-            </a:pPr>
-            <a:r>
-              <a:rPr b="0" i="0" lang="en-US" sz="1400" u="none" cap="none" strike="noStrike">
-                <a:solidFill>
-                  <a:srgbClr val="8DA9C4"/>
-                </a:solidFill>
-                <a:latin typeface="Calibri"/>
-                <a:ea typeface="Calibri"/>
-                <a:cs typeface="Calibri"/>
-                <a:sym typeface="Calibri"/>
-              </a:rPr>
-              <a:t>degradaciones</a:t>
-            </a:r>
-            <a:endParaRPr b="0" i="0" sz="1400" u="none" cap="none" strike="noStrike">
-              <a:solidFill>
-                <a:schemeClr val="dk1"/>
-              </a:solidFill>
-              <a:latin typeface="Calibri"/>
-              <a:ea typeface="Calibri"/>
-              <a:cs typeface="Calibri"/>
-              <a:sym typeface="Calibri"/>
-            </a:endParaRPr>
-          </a:p>
-          <a:p>
-            <a:pPr indent="0" lvl="0" marL="0" marR="0" rtl="0" algn="ctr">
-              <a:spcBef>
-                <a:spcPts val="0"/>
-              </a:spcBef>
-              <a:spcAft>
-                <a:spcPts val="0"/>
-              </a:spcAft>
-              <a:buClr>
-                <a:srgbClr val="8DA9C4"/>
-              </a:buClr>
-              <a:buSzPts val="1400"/>
-              <a:buFont typeface="Calibri"/>
-              <a:buNone/>
-            </a:pPr>
-            <a:r>
-              <a:rPr b="0" i="0" lang="en-US" sz="1400" u="none" cap="none" strike="noStrike">
-                <a:solidFill>
-                  <a:srgbClr val="8DA9C4"/>
-                </a:solidFill>
-                <a:latin typeface="Calibri"/>
-                <a:ea typeface="Calibri"/>
-                <a:cs typeface="Calibri"/>
-                <a:sym typeface="Calibri"/>
-              </a:rPr>
-              <a:t>significativas (p &lt; 0,05)</a:t>
-            </a:r>
-            <a:endParaRPr b="0" i="0" sz="1400" u="none" cap="none" strike="noStrike">
-              <a:solidFill>
-                <a:schemeClr val="dk1"/>
-              </a:solidFill>
-              <a:latin typeface="Calibri"/>
-              <a:ea typeface="Calibri"/>
-              <a:cs typeface="Calibri"/>
-              <a:sym typeface="Calibri"/>
-            </a:endParaRPr>
-          </a:p>
-        </p:txBody>
-      </p:sp>
-      <p:sp>
-        <p:nvSpPr>
-          <p:cNvPr id="231" name="Google Shape;231;p13"/>
-          <p:cNvSpPr/>
-          <p:nvPr/>
-        </p:nvSpPr>
-        <p:spPr>
-          <a:xfrm>
-            <a:off x="822960" y="4206240"/>
-            <a:ext cx="10515600" cy="13716"/>
-          </a:xfrm>
-          <a:prstGeom prst="rect">
-            <a:avLst/>
-          </a:prstGeom>
-          <a:solidFill>
-            <a:srgbClr val="23406E"/>
-          </a:solidFill>
-          <a:ln>
-            <a:noFill/>
-          </a:ln>
-        </p:spPr>
-        <p:txBody>
-          <a:bodyPr anchorCtr="0" anchor="ctr" bIns="91425" lIns="91425" spcFirstLastPara="1" rIns="91425" wrap="square" tIns="91425">
-            <a:noAutofit/>
-          </a:bodyPr>
-          <a:lstStyle/>
-          <a:p>
-            <a:pPr indent="0" lvl="0" marL="0" rtl="0" algn="l">
-              <a:spcBef>
-                <a:spcPts val="0"/>
-              </a:spcBef>
-              <a:spcAft>
-                <a:spcPts val="0"/>
-              </a:spcAft>
-              <a:buNone/>
-            </a:pPr>
-            <a:r>
-              <a:t/>
-            </a:r>
-            <a:endParaRPr/>
-          </a:p>
-        </p:txBody>
-      </p:sp>
-      <p:sp>
-        <p:nvSpPr>
-          <p:cNvPr id="232" name="Google Shape;232;p13"/>
-          <p:cNvSpPr txBox="1"/>
-          <p:nvPr/>
-        </p:nvSpPr>
-        <p:spPr>
-          <a:xfrm>
-            <a:off x="822960" y="4434840"/>
-            <a:ext cx="10515600" cy="914400"/>
-          </a:xfrm>
-          <a:prstGeom prst="rect">
-            <a:avLst/>
-          </a:prstGeom>
-          <a:noFill/>
-          <a:ln>
-            <a:noFill/>
-          </a:ln>
-        </p:spPr>
-        <p:txBody>
-          <a:bodyPr anchorCtr="0" anchor="ctr" bIns="0" lIns="0" spcFirstLastPara="1" rIns="0" wrap="square" tIns="0">
-            <a:noAutofit/>
-          </a:bodyPr>
-          <a:lstStyle/>
-          <a:p>
-            <a:pPr indent="0" lvl="0" marL="0" marR="0" rtl="0" algn="l">
-              <a:spcBef>
-                <a:spcPts val="0"/>
-              </a:spcBef>
-              <a:spcAft>
-                <a:spcPts val="0"/>
-              </a:spcAft>
-              <a:buClr>
-                <a:srgbClr val="8DA9C4"/>
-              </a:buClr>
-              <a:buSzPts val="1250"/>
-              <a:buFont typeface="Calibri"/>
-              <a:buNone/>
-            </a:pPr>
-            <a:r>
-              <a:rPr b="0" i="0" lang="en-US" sz="1250" u="none" cap="none" strike="noStrike">
-                <a:solidFill>
-                  <a:srgbClr val="8DA9C4"/>
-                </a:solidFill>
-                <a:latin typeface="Calibri"/>
-                <a:ea typeface="Calibri"/>
-                <a:cs typeface="Calibri"/>
-                <a:sym typeface="Calibri"/>
-              </a:rPr>
-              <a:t>Contraste de medias pareado por semilla frente a la referencia sin sintéticos. Las seis degradaciones:</a:t>
-            </a:r>
-            <a:endParaRPr b="0" i="0" sz="1250" u="none" cap="none" strike="noStrike">
-              <a:solidFill>
-                <a:schemeClr val="dk1"/>
-              </a:solidFill>
-              <a:latin typeface="Calibri"/>
-              <a:ea typeface="Calibri"/>
-              <a:cs typeface="Calibri"/>
-              <a:sym typeface="Calibri"/>
-            </a:endParaRPr>
-          </a:p>
-          <a:p>
-            <a:pPr indent="0" lvl="0" marL="0" marR="0" rtl="0" algn="l">
-              <a:spcBef>
-                <a:spcPts val="0"/>
-              </a:spcBef>
-              <a:spcAft>
-                <a:spcPts val="0"/>
-              </a:spcAft>
-              <a:buClr>
-                <a:srgbClr val="8DA9C4"/>
-              </a:buClr>
-              <a:buSzPts val="1250"/>
-              <a:buFont typeface="Calibri"/>
-              <a:buNone/>
-            </a:pPr>
-            <a:r>
-              <a:rPr b="0" i="0" lang="en-US" sz="1250" u="none" cap="none" strike="noStrike">
-                <a:solidFill>
-                  <a:srgbClr val="8DA9C4"/>
-                </a:solidFill>
-                <a:latin typeface="Calibri"/>
-                <a:ea typeface="Calibri"/>
-                <a:cs typeface="Calibri"/>
-                <a:sym typeface="Calibri"/>
-              </a:rPr>
-              <a:t>CVAE en validación a proporción 1, 2 y 4 (−0,030 / −0,043 / −0,064); difusión a 0,5 (−0,037); ruido en</a:t>
-            </a:r>
-            <a:endParaRPr b="0" i="0" sz="1250" u="none" cap="none" strike="noStrike">
-              <a:solidFill>
-                <a:schemeClr val="dk1"/>
-              </a:solidFill>
-              <a:latin typeface="Calibri"/>
-              <a:ea typeface="Calibri"/>
-              <a:cs typeface="Calibri"/>
-              <a:sym typeface="Calibri"/>
-            </a:endParaRPr>
-          </a:p>
-          <a:p>
-            <a:pPr indent="0" lvl="0" marL="0" marR="0" rtl="0" algn="l">
-              <a:spcBef>
-                <a:spcPts val="0"/>
-              </a:spcBef>
-              <a:spcAft>
-                <a:spcPts val="0"/>
-              </a:spcAft>
-              <a:buClr>
-                <a:srgbClr val="8DA9C4"/>
-              </a:buClr>
-              <a:buSzPts val="1250"/>
-              <a:buFont typeface="Calibri"/>
-              <a:buNone/>
-            </a:pPr>
-            <a:r>
-              <a:rPr b="0" i="0" lang="en-US" sz="1250" u="none" cap="none" strike="noStrike">
-                <a:solidFill>
-                  <a:srgbClr val="8DA9C4"/>
-                </a:solidFill>
-                <a:latin typeface="Calibri"/>
-                <a:ea typeface="Calibri"/>
-                <a:cs typeface="Calibri"/>
-                <a:sym typeface="Calibri"/>
-              </a:rPr>
-              <a:t>test a proporción 2 (−0,058).</a:t>
-            </a:r>
-            <a:endParaRPr b="0" i="0" sz="1250" u="none" cap="none" strike="noStrike">
-              <a:solidFill>
-                <a:schemeClr val="dk1"/>
-              </a:solidFill>
-              <a:latin typeface="Calibri"/>
-              <a:ea typeface="Calibri"/>
-              <a:cs typeface="Calibri"/>
-              <a:sym typeface="Calibri"/>
-            </a:endParaRPr>
-          </a:p>
-        </p:txBody>
-      </p:sp>
-      <p:sp>
-        <p:nvSpPr>
-          <p:cNvPr id="233" name="Google Shape;233;p13"/>
-          <p:cNvSpPr txBox="1"/>
-          <p:nvPr/>
-        </p:nvSpPr>
-        <p:spPr>
-          <a:xfrm>
-            <a:off x="822960" y="5577840"/>
-            <a:ext cx="10515600" cy="640080"/>
-          </a:xfrm>
-          <a:prstGeom prst="rect">
-            <a:avLst/>
-          </a:prstGeom>
-          <a:noFill/>
-          <a:ln>
-            <a:noFill/>
-          </a:ln>
-        </p:spPr>
-        <p:txBody>
-          <a:bodyPr anchorCtr="0" anchor="ctr" bIns="0" lIns="0" spcFirstLastPara="1" rIns="0" wrap="square" tIns="0">
-            <a:noAutofit/>
-          </a:bodyPr>
-          <a:lstStyle/>
-          <a:p>
-            <a:pPr indent="0" lvl="0" marL="0" marR="0" rtl="0" algn="l">
-              <a:spcBef>
-                <a:spcPts val="0"/>
-              </a:spcBef>
-              <a:spcAft>
-                <a:spcPts val="0"/>
-              </a:spcAft>
-              <a:buClr>
-                <a:srgbClr val="FFFFFF"/>
-              </a:buClr>
-              <a:buSzPts val="1700"/>
-              <a:buFont typeface="Cambria"/>
-              <a:buNone/>
-            </a:pPr>
-            <a:r>
-              <a:rPr b="1" i="1" lang="en-US" sz="1700" u="none" cap="none" strike="noStrike">
-                <a:solidFill>
-                  <a:srgbClr val="FFFFFF"/>
-                </a:solidFill>
-                <a:latin typeface="Cambria"/>
-                <a:ea typeface="Cambria"/>
-                <a:cs typeface="Cambria"/>
-                <a:sym typeface="Cambria"/>
-              </a:rPr>
-              <a:t>La respuesta a la pregunta del taller, con estos generadores y este problema, es que no.</a:t>
-            </a:r>
-            <a:endParaRPr b="0" i="0" sz="1700" u="none" cap="none" strike="noStrike">
-              <a:solidFill>
-                <a:schemeClr val="dk1"/>
-              </a:solidFill>
-              <a:latin typeface="Calibri"/>
-              <a:ea typeface="Calibri"/>
-              <a:cs typeface="Calibri"/>
-              <a:sym typeface="Calibri"/>
-            </a:endParaRPr>
-          </a:p>
-        </p:txBody>
-      </p:sp>
-      <p:sp>
-        <p:nvSpPr>
-          <p:cNvPr id="234" name="Google Shape;234;p13"/>
-          <p:cNvSpPr txBox="1"/>
-          <p:nvPr/>
-        </p:nvSpPr>
-        <p:spPr>
-          <a:xfrm>
-            <a:off x="457200" y="6473952"/>
-            <a:ext cx="7315200" cy="274320"/>
-          </a:xfrm>
-          <a:prstGeom prst="rect">
-            <a:avLst/>
-          </a:prstGeom>
-          <a:noFill/>
-          <a:ln>
-            <a:noFill/>
-          </a:ln>
-        </p:spPr>
-        <p:txBody>
-          <a:bodyPr anchorCtr="0" anchor="ctr" bIns="0" lIns="0" spcFirstLastPara="1" rIns="0" wrap="square" tIns="0">
-            <a:noAutofit/>
-          </a:bodyPr>
-          <a:lstStyle/>
-          <a:p>
-            <a:pPr indent="0" lvl="0" marL="0" marR="0" rtl="0" algn="l">
-              <a:spcBef>
-                <a:spcPts val="0"/>
-              </a:spcBef>
-              <a:spcAft>
-                <a:spcPts val="0"/>
-              </a:spcAft>
-              <a:buClr>
-                <a:srgbClr val="5B7089"/>
-              </a:buClr>
-              <a:buSzPts val="900"/>
-              <a:buFont typeface="Calibri"/>
-              <a:buNone/>
-            </a:pPr>
-            <a:r>
-              <a:rPr b="0" i="0" lang="en-US" sz="900" u="none" cap="none" strike="noStrike">
-                <a:solidFill>
-                  <a:srgbClr val="5B7089"/>
-                </a:solidFill>
-                <a:latin typeface="Calibri"/>
-                <a:ea typeface="Calibri"/>
-                <a:cs typeface="Calibri"/>
-                <a:sym typeface="Calibri"/>
-              </a:rPr>
-              <a:t>Generación de datos financieros sintéticos  ·  Taller B5-T1</a:t>
-            </a:r>
-            <a:endParaRPr b="0" i="0" sz="900" u="none" cap="none" strike="noStrike">
-              <a:solidFill>
-                <a:schemeClr val="dk1"/>
-              </a:solidFill>
-              <a:latin typeface="Calibri"/>
-              <a:ea typeface="Calibri"/>
-              <a:cs typeface="Calibri"/>
-              <a:sym typeface="Calibri"/>
-            </a:endParaRPr>
-          </a:p>
-        </p:txBody>
-      </p:sp>
-      <p:sp>
-        <p:nvSpPr>
-          <p:cNvPr id="235" name="Google Shape;235;p13"/>
-          <p:cNvSpPr txBox="1"/>
-          <p:nvPr/>
-        </p:nvSpPr>
-        <p:spPr>
-          <a:xfrm>
-            <a:off x="11277295" y="6473952"/>
-            <a:ext cx="457200" cy="274320"/>
-          </a:xfrm>
-          <a:prstGeom prst="rect">
-            <a:avLst/>
-          </a:prstGeom>
-          <a:noFill/>
-          <a:ln>
-            <a:noFill/>
-          </a:ln>
-        </p:spPr>
-        <p:txBody>
-          <a:bodyPr anchorCtr="0" anchor="ctr" bIns="0" lIns="0" spcFirstLastPara="1" rIns="0" wrap="square" tIns="0">
-            <a:noAutofit/>
-          </a:bodyPr>
-          <a:lstStyle/>
-          <a:p>
-            <a:pPr indent="0" lvl="0" marL="0" marR="0" rtl="0" algn="r">
-              <a:spcBef>
-                <a:spcPts val="0"/>
-              </a:spcBef>
-              <a:spcAft>
-                <a:spcPts val="0"/>
-              </a:spcAft>
-              <a:buClr>
-                <a:srgbClr val="5B7089"/>
-              </a:buClr>
-              <a:buSzPts val="900"/>
-              <a:buFont typeface="Calibri"/>
-              <a:buNone/>
-            </a:pPr>
-            <a:r>
-              <a:rPr b="0" i="0" lang="en-US" sz="900" u="none" cap="none" strike="noStrike">
-                <a:solidFill>
-                  <a:srgbClr val="5B7089"/>
-                </a:solidFill>
-                <a:latin typeface="Calibri"/>
-                <a:ea typeface="Calibri"/>
-                <a:cs typeface="Calibri"/>
-                <a:sym typeface="Calibri"/>
-              </a:rPr>
-              <a:t>10</a:t>
-            </a:r>
-            <a:endParaRPr b="0" i="0" sz="900" u="none" cap="none" strike="noStrike">
-              <a:solidFill>
-                <a:schemeClr val="dk1"/>
-              </a:solidFill>
-              <a:latin typeface="Calibri"/>
-              <a:ea typeface="Calibri"/>
-              <a:cs typeface="Calibri"/>
-              <a:sym typeface="Calibri"/>
-            </a:endParaRPr>
-          </a:p>
-        </p:txBody>
-      </p:sp>
-    </p:spTree>
-  </p:cSld>
-  <p:clrMapOvr>
-    <a:masterClrMapping/>
-  </p:clrMapOvr>
-</p:sld>
-</file>
-
 <file path=ppt/slides/slide11.xml><?xml version="1.0" encoding="utf-8"?>
 <p:sld xmlns:a="http://schemas.openxmlformats.org/drawingml/2006/main" xmlns:r="http://schemas.openxmlformats.org/officeDocument/2006/relationships" xmlns:mc="http://schemas.openxmlformats.org/markup-compatibility/2006" xmlns:mv="urn:schemas-microsoft-com:mac:vml" xmlns:p="http://schemas.openxmlformats.org/presentationml/2006/main" xmlns:c="http://schemas.openxmlformats.org/drawingml/2006/chart" xmlns:dgm="http://schemas.openxmlformats.org/drawingml/2006/diagram" xmlns:o="urn:schemas-microsoft-com:office:office" xmlns:v="urn:schemas-microsoft-com:vml" xmlns:pvml="urn:schemas-microsoft-com:office:powerpoint" xmlns:com="http://schemas.openxmlformats.org/drawingml/2006/compatibility" xmlns:p14="http://schemas.microsoft.com/office/powerpoint/2010/main" xmlns:p15="http://schemas.microsoft.com/office/powerpoint/2012/main" xmlns:ahyp="http://schemas.microsoft.com/office/drawing/2018/hyperlinkcolor">
   <p:cSld>
@@ -6224,17 +5051,8 @@
                 <a:cs typeface="Cambria"/>
                 <a:sym typeface="Cambria"/>
               </a:rPr>
-              <a:t>La misma conclusión, en una imagen</a:t>
-            </a:r>
-            <a:endParaRPr b="0" i="0" sz="3200" u="none" cap="none" strike="noStrike">
-              <a:solidFill>
-                <a:schemeClr val="dk1"/>
-              </a:solidFill>
-              <a:latin typeface="Calibri"/>
-              <a:ea typeface="Calibri"/>
-              <a:cs typeface="Calibri"/>
-              <a:sym typeface="Calibri"/>
-            </a:endParaRPr>
+              <a:t xml:space="preserve">¿Alguna de esas subidas resiste el contraste?</a:t>
+            </a:r>
           </a:p>
         </p:txBody>
       </p:sp>
@@ -6253,7 +5071,7 @@
         </p:blipFill>
         <p:spPr>
           <a:xfrm>
-            <a:off x="640080" y="1508760"/>
+            <a:off x="4160520" y="1572768"/>
             <a:ext cx="7360920" cy="4187952"/>
           </a:xfrm>
           <a:prstGeom prst="rect">
@@ -6265,284 +5083,6 @@
           </a:ln>
         </p:spPr>
       </p:pic>
-      <p:sp>
-        <p:nvSpPr>
-          <p:cNvPr id="244" name="Google Shape;244;p14"/>
-          <p:cNvSpPr/>
-          <p:nvPr/>
-        </p:nvSpPr>
-        <p:spPr>
-          <a:xfrm>
-            <a:off x="8229600" y="1508760"/>
-            <a:ext cx="3291840" cy="4187952"/>
-          </a:xfrm>
-          <a:prstGeom prst="roundRect">
-            <a:avLst>
-              <a:gd fmla="val 2778" name="adj"/>
-            </a:avLst>
-          </a:prstGeom>
-          <a:solidFill>
-            <a:srgbClr val="0B2545"/>
-          </a:solidFill>
-          <a:ln>
-            <a:noFill/>
-          </a:ln>
-        </p:spPr>
-        <p:txBody>
-          <a:bodyPr anchorCtr="0" anchor="ctr" bIns="91425" lIns="91425" spcFirstLastPara="1" rIns="91425" wrap="square" tIns="91425">
-            <a:noAutofit/>
-          </a:bodyPr>
-          <a:lstStyle/>
-          <a:p>
-            <a:pPr indent="0" lvl="0" marL="0" rtl="0" algn="l">
-              <a:spcBef>
-                <a:spcPts val="0"/>
-              </a:spcBef>
-              <a:spcAft>
-                <a:spcPts val="0"/>
-              </a:spcAft>
-              <a:buNone/>
-            </a:pPr>
-            <a:r>
-              <a:t/>
-            </a:r>
-            <a:endParaRPr/>
-          </a:p>
-        </p:txBody>
-      </p:sp>
-      <p:sp>
-        <p:nvSpPr>
-          <p:cNvPr id="245" name="Google Shape;245;p14"/>
-          <p:cNvSpPr txBox="1"/>
-          <p:nvPr/>
-        </p:nvSpPr>
-        <p:spPr>
-          <a:xfrm>
-            <a:off x="8503920" y="1737360"/>
-            <a:ext cx="2743200" cy="320040"/>
-          </a:xfrm>
-          <a:prstGeom prst="rect">
-            <a:avLst/>
-          </a:prstGeom>
-          <a:noFill/>
-          <a:ln>
-            <a:noFill/>
-          </a:ln>
-        </p:spPr>
-        <p:txBody>
-          <a:bodyPr anchorCtr="0" anchor="ctr" bIns="0" lIns="0" spcFirstLastPara="1" rIns="0" wrap="square" tIns="0">
-            <a:noAutofit/>
-          </a:bodyPr>
-          <a:lstStyle/>
-          <a:p>
-            <a:pPr indent="0" lvl="0" marL="0" marR="0" rtl="0" algn="l">
-              <a:spcBef>
-                <a:spcPts val="0"/>
-              </a:spcBef>
-              <a:spcAft>
-                <a:spcPts val="0"/>
-              </a:spcAft>
-              <a:buClr>
-                <a:srgbClr val="8DA9C4"/>
-              </a:buClr>
-              <a:buSzPts val="1300"/>
-              <a:buFont typeface="Calibri"/>
-              <a:buNone/>
-            </a:pPr>
-            <a:r>
-              <a:rPr b="1" i="0" lang="en-US" sz="1300" u="none" cap="none" strike="noStrike">
-                <a:solidFill>
-                  <a:srgbClr val="8DA9C4"/>
-                </a:solidFill>
-                <a:latin typeface="Calibri"/>
-                <a:ea typeface="Calibri"/>
-                <a:cs typeface="Calibri"/>
-                <a:sym typeface="Calibri"/>
-              </a:rPr>
-              <a:t>Cómo leerlo</a:t>
-            </a:r>
-            <a:endParaRPr b="0" i="0" sz="1300" u="none" cap="none" strike="noStrike">
-              <a:solidFill>
-                <a:schemeClr val="dk1"/>
-              </a:solidFill>
-              <a:latin typeface="Calibri"/>
-              <a:ea typeface="Calibri"/>
-              <a:cs typeface="Calibri"/>
-              <a:sym typeface="Calibri"/>
-            </a:endParaRPr>
-          </a:p>
-        </p:txBody>
-      </p:sp>
-      <p:sp>
-        <p:nvSpPr>
-          <p:cNvPr id="246" name="Google Shape;246;p14"/>
-          <p:cNvSpPr txBox="1"/>
-          <p:nvPr/>
-        </p:nvSpPr>
-        <p:spPr>
-          <a:xfrm>
-            <a:off x="8503920" y="2103120"/>
-            <a:ext cx="2743200" cy="3383280"/>
-          </a:xfrm>
-          <a:prstGeom prst="rect">
-            <a:avLst/>
-          </a:prstGeom>
-          <a:noFill/>
-          <a:ln>
-            <a:noFill/>
-          </a:ln>
-        </p:spPr>
-        <p:txBody>
-          <a:bodyPr anchorCtr="0" anchor="t" bIns="0" lIns="0" spcFirstLastPara="1" rIns="0" wrap="square" tIns="0">
-            <a:noAutofit/>
-          </a:bodyPr>
-          <a:lstStyle/>
-          <a:p>
-            <a:pPr indent="0" lvl="0" marL="0" marR="0" rtl="0" algn="l">
-              <a:lnSpc>
-                <a:spcPct val="125000"/>
-              </a:lnSpc>
-              <a:spcBef>
-                <a:spcPts val="0"/>
-              </a:spcBef>
-              <a:spcAft>
-                <a:spcPts val="0"/>
-              </a:spcAft>
-              <a:buClr>
-                <a:srgbClr val="FFFFFF"/>
-              </a:buClr>
-              <a:buSzPts val="1250"/>
-              <a:buFont typeface="Calibri"/>
-              <a:buNone/>
-            </a:pPr>
-            <a:r>
-              <a:rPr b="0" i="0" lang="en-US" sz="1250" u="none" cap="none" strike="noStrike">
-                <a:solidFill>
-                  <a:srgbClr val="FFFFFF"/>
-                </a:solidFill>
-                <a:latin typeface="Calibri"/>
-                <a:ea typeface="Calibri"/>
-                <a:cs typeface="Calibri"/>
-                <a:sym typeface="Calibri"/>
-              </a:rPr>
-              <a:t>Cada barra es la </a:t>
-            </a:r>
-            <a:r>
-              <a:rPr b="1" i="1" lang="en-US" sz="1250" u="none" cap="none" strike="noStrike">
-                <a:solidFill>
-                  <a:srgbClr val="FFFFFF"/>
-                </a:solidFill>
-                <a:latin typeface="Calibri"/>
-                <a:ea typeface="Calibri"/>
-                <a:cs typeface="Calibri"/>
-                <a:sym typeface="Calibri"/>
-              </a:rPr>
-              <a:t>mejor</a:t>
-            </a:r>
-            <a:r>
-              <a:rPr b="0" i="0" lang="en-US" sz="1250" u="none" cap="none" strike="noStrike">
-                <a:solidFill>
-                  <a:srgbClr val="FFFFFF"/>
-                </a:solidFill>
-                <a:latin typeface="Calibri"/>
-                <a:ea typeface="Calibri"/>
-                <a:cs typeface="Calibri"/>
-                <a:sym typeface="Calibri"/>
-              </a:rPr>
-              <a:t> variación que consigue ese generador; la línea es cuánto varía entre semillas.</a:t>
-            </a:r>
-            <a:br>
-              <a:rPr b="0" i="0" lang="en-US" sz="1250" u="none" cap="none" strike="noStrike">
-                <a:solidFill>
-                  <a:srgbClr val="FFFFFF"/>
-                </a:solidFill>
-                <a:latin typeface="Calibri"/>
-                <a:ea typeface="Calibri"/>
-                <a:cs typeface="Calibri"/>
-                <a:sym typeface="Calibri"/>
-              </a:rPr>
-            </a:br>
-            <a:br>
-              <a:rPr b="0" i="0" lang="en-US" sz="1250" u="none" cap="none" strike="noStrike">
-                <a:solidFill>
-                  <a:srgbClr val="FFFFFF"/>
-                </a:solidFill>
-                <a:latin typeface="Calibri"/>
-                <a:ea typeface="Calibri"/>
-                <a:cs typeface="Calibri"/>
-                <a:sym typeface="Calibri"/>
-              </a:rPr>
-            </a:br>
-            <a:r>
-              <a:rPr b="1" i="0" lang="en-US" sz="1250" u="none" cap="none" strike="noStrike">
-                <a:solidFill>
-                  <a:srgbClr val="FFFFFF"/>
-                </a:solidFill>
-                <a:latin typeface="Calibri"/>
-                <a:ea typeface="Calibri"/>
-                <a:cs typeface="Calibri"/>
-                <a:sym typeface="Calibri"/>
-              </a:rPr>
-              <a:t>Cuando esa línea cruza el cero</a:t>
-            </a:r>
-            <a:r>
-              <a:rPr b="0" i="0" lang="en-US" sz="1250" u="none" cap="none" strike="noStrike">
-                <a:solidFill>
-                  <a:srgbClr val="FFFFFF"/>
-                </a:solidFill>
-                <a:latin typeface="Calibri"/>
-                <a:ea typeface="Calibri"/>
-                <a:cs typeface="Calibri"/>
-                <a:sym typeface="Calibri"/>
-              </a:rPr>
-              <a:t>, la subida no se distingue del ruido de la propia inicialización.</a:t>
-            </a:r>
-            <a:br>
-              <a:rPr b="0" i="0" lang="en-US" sz="1250" u="none" cap="none" strike="noStrike">
-                <a:solidFill>
-                  <a:srgbClr val="FFFFFF"/>
-                </a:solidFill>
-                <a:latin typeface="Calibri"/>
-                <a:ea typeface="Calibri"/>
-                <a:cs typeface="Calibri"/>
-                <a:sym typeface="Calibri"/>
-              </a:rPr>
-            </a:br>
-            <a:br>
-              <a:rPr b="0" i="0" lang="en-US" sz="1250" u="none" cap="none" strike="noStrike">
-                <a:solidFill>
-                  <a:srgbClr val="FFFFFF"/>
-                </a:solidFill>
-                <a:latin typeface="Calibri"/>
-                <a:ea typeface="Calibri"/>
-                <a:cs typeface="Calibri"/>
-                <a:sym typeface="Calibri"/>
-              </a:rPr>
-            </a:br>
-            <a:r>
-              <a:rPr b="1" i="0" lang="en-US" sz="1250" u="none" cap="none" strike="noStrike">
-                <a:solidFill>
-                  <a:srgbClr val="D64550"/>
-                </a:solidFill>
-                <a:latin typeface="Calibri"/>
-                <a:ea typeface="Calibri"/>
-                <a:cs typeface="Calibri"/>
-                <a:sym typeface="Calibri"/>
-              </a:rPr>
-              <a:t>Las cuatro la cruzan.</a:t>
-            </a:r>
-            <a:endParaRPr b="0" i="0" sz="1250" u="none" cap="none" strike="noStrike">
-              <a:solidFill>
-                <a:schemeClr val="dk1"/>
-              </a:solidFill>
-              <a:latin typeface="Calibri"/>
-              <a:ea typeface="Calibri"/>
-              <a:cs typeface="Calibri"/>
-              <a:sym typeface="Calibri"/>
-            </a:endParaRPr>
-          </a:p>
-        </p:txBody>
-      </p:sp>
       <p:sp>
         <p:nvSpPr>
           <p:cNvPr id="247" name="Google Shape;247;p14"/>
@@ -6655,9 +5195,63 @@
                 <a:cs typeface="Calibri"/>
                 <a:sym typeface="Calibri"/>
               </a:rPr>
-              <a:t>11</a:t>
-            </a:r>
-            <a:endParaRPr b="0" i="0" sz="900" u="none" cap="none" strike="noStrike">
+              <a:t xml:space="preserve">11</a:t>
+            </a:r>
+          </a:p>
+        </p:txBody>
+      </p:sp>
+      <p:sp>
+        <p:nvSpPr>
+          <p:cNvPr id="225" name="Google Shape;225;p13"/>
+          <p:cNvSpPr txBox="1"/>
+          <p:nvPr/>
+        </p:nvSpPr>
+        <p:spPr>
+          <a:xfrm>
+            <a:off x="640080" y="1691640"/>
+            <a:ext cx="3154680" cy="960120"/>
+          </a:xfrm>
+          <a:prstGeom prst="rect">
+            <a:avLst/>
+          </a:prstGeom>
+          <a:noFill/>
+          <a:ln>
+            <a:noFill/>
+          </a:ln>
+        </p:spPr>
+        <p:txBody>
+          <a:bodyPr anchorCtr="0" anchor="ctr" bIns="0" lIns="0" spcFirstLastPara="1" rIns="0" wrap="square" tIns="0">
+            <a:noAutofit/>
+          </a:bodyPr>
+          <a:lstStyle/>
+          <a:p>
+            <a:pPr indent="0" lvl="0" marL="0" marR="0" rtl="0" algn="ctr">
+              <a:spcBef>
+                <a:spcPts val="0"/>
+              </a:spcBef>
+              <a:spcAft>
+                <a:spcPts val="0"/>
+              </a:spcAft>
+              <a:buClr>
+                <a:srgbClr val="8DA9C4"/>
+              </a:buClr>
+              <a:buSzPts val="8200"/>
+              <a:buFont typeface="Cambria"/>
+              <a:buNone/>
+            </a:pPr>
+            <a:r>
+              <a:rPr b="1" i="0" lang="en-US" sz="8200" u="none" cap="none" strike="noStrike">
+                <a:solidFill>
+                  <a:srgbClr val="8DA9C4"/>
+                </a:solidFill>
+                <a:latin typeface="Cambria"/>
+                <a:ea typeface="Cambria"/>
+                <a:cs typeface="Cambria"/>
+                <a:sym typeface="Cambria"/>
+              </a:rPr>
+              <a:t>20</a:t>
+            </a:r>
+            <a:endParaRPr b="0" i="0" sz="8200" u="none" cap="none" strike="noStrike">
               <a:solidFill>
                 <a:schemeClr val="dk1"/>
               </a:solidFill>
@@ -6666,6 +5260,486 @@
               <a:cs typeface="Calibri"/>
               <a:sym typeface="Calibri"/>
             </a:endParaRPr>
+          </a:p>
+        </p:txBody>
+      </p:sp>
+      <p:sp>
+        <p:nvSpPr>
+          <p:cNvPr id="226" name="Google Shape;226;p13"/>
+          <p:cNvSpPr txBox="1"/>
+          <p:nvPr/>
+        </p:nvSpPr>
+        <p:spPr>
+          <a:xfrm>
+            <a:off x="640080" y="2624328"/>
+            <a:ext cx="3154680" cy="457200"/>
+          </a:xfrm>
+          <a:prstGeom prst="rect">
+            <a:avLst/>
+          </a:prstGeom>
+          <a:noFill/>
+          <a:ln>
+            <a:noFill/>
+          </a:ln>
+        </p:spPr>
+        <p:txBody>
+          <a:bodyPr anchorCtr="0" anchor="ctr" bIns="0" lIns="0" spcFirstLastPara="1" rIns="0" wrap="square" tIns="0">
+            <a:noAutofit/>
+          </a:bodyPr>
+          <a:lstStyle/>
+          <a:p>
+            <a:pPr indent="0" lvl="0" marL="0" marR="0" rtl="0" algn="ctr">
+              <a:spcBef>
+                <a:spcPts val="0"/>
+              </a:spcBef>
+              <a:spcAft>
+                <a:spcPts val="0"/>
+              </a:spcAft>
+              <a:buClr>
+                <a:srgbClr val="8DA9C4"/>
+              </a:buClr>
+              <a:buSzPts val="1400"/>
+              <a:buFont typeface="Calibri"/>
+              <a:buNone/>
+            </a:pPr>
+            <a:r>
+              <a:rPr b="0" i="0" lang="en-US" sz="1400" u="none" cap="none" strike="noStrike">
+                <a:solidFill>
+                  <a:srgbClr val="8DA9C4"/>
+                </a:solidFill>
+                <a:latin typeface="Calibri"/>
+                <a:ea typeface="Calibri"/>
+                <a:cs typeface="Calibri"/>
+                <a:sym typeface="Calibri"/>
+              </a:rPr>
+              <a:t>configuraciones</a:t>
+            </a:r>
+            <a:endParaRPr b="0" i="0" sz="1400" u="none" cap="none" strike="noStrike">
+              <a:solidFill>
+                <a:schemeClr val="dk1"/>
+              </a:solidFill>
+              <a:latin typeface="Calibri"/>
+              <a:ea typeface="Calibri"/>
+              <a:cs typeface="Calibri"/>
+              <a:sym typeface="Calibri"/>
+            </a:endParaRPr>
+          </a:p>
+          <a:p>
+            <a:pPr indent="0" lvl="0" marL="0" marR="0" rtl="0" algn="ctr">
+              <a:spcBef>
+                <a:spcPts val="0"/>
+              </a:spcBef>
+              <a:spcAft>
+                <a:spcPts val="0"/>
+              </a:spcAft>
+              <a:buClr>
+                <a:srgbClr val="8DA9C4"/>
+              </a:buClr>
+              <a:buSzPts val="1400"/>
+              <a:buFont typeface="Calibri"/>
+              <a:buNone/>
+            </a:pPr>
+            <a:r>
+              <a:rPr b="0" i="0" lang="en-US" sz="1400" u="none" cap="none" strike="noStrike">
+                <a:solidFill>
+                  <a:srgbClr val="8DA9C4"/>
+                </a:solidFill>
+                <a:latin typeface="Calibri"/>
+                <a:ea typeface="Calibri"/>
+                <a:cs typeface="Calibri"/>
+                <a:sym typeface="Calibri"/>
+              </a:rPr>
+              <a:t>contrastadas</a:t>
+            </a:r>
+            <a:endParaRPr b="0" i="0" sz="1400" u="none" cap="none" strike="noStrike">
+              <a:solidFill>
+                <a:schemeClr val="dk1"/>
+              </a:solidFill>
+              <a:latin typeface="Calibri"/>
+              <a:ea typeface="Calibri"/>
+              <a:cs typeface="Calibri"/>
+              <a:sym typeface="Calibri"/>
+            </a:endParaRPr>
+          </a:p>
+        </p:txBody>
+      </p:sp>
+      <p:sp>
+        <p:nvSpPr>
+          <p:cNvPr id="227" name="Google Shape;227;p13"/>
+          <p:cNvSpPr txBox="1"/>
+          <p:nvPr/>
+        </p:nvSpPr>
+        <p:spPr>
+          <a:xfrm>
+            <a:off x="640080" y="3127248"/>
+            <a:ext cx="3154680" cy="960120"/>
+          </a:xfrm>
+          <a:prstGeom prst="rect">
+            <a:avLst/>
+          </a:prstGeom>
+          <a:noFill/>
+          <a:ln>
+            <a:noFill/>
+          </a:ln>
+        </p:spPr>
+        <p:txBody>
+          <a:bodyPr anchorCtr="0" anchor="ctr" bIns="0" lIns="0" spcFirstLastPara="1" rIns="0" wrap="square" tIns="0">
+            <a:noAutofit/>
+          </a:bodyPr>
+          <a:lstStyle/>
+          <a:p>
+            <a:pPr indent="0" lvl="0" marL="0" marR="0" rtl="0" algn="ctr">
+              <a:spcBef>
+                <a:spcPts val="0"/>
+              </a:spcBef>
+              <a:spcAft>
+                <a:spcPts val="0"/>
+              </a:spcAft>
+              <a:buClr>
+                <a:srgbClr val="D64550"/>
+              </a:buClr>
+              <a:buSzPts val="8200"/>
+              <a:buFont typeface="Cambria"/>
+              <a:buNone/>
+            </a:pPr>
+            <a:r>
+              <a:rPr b="1" i="0" lang="en-US" sz="8200" u="none" cap="none" strike="noStrike">
+                <a:solidFill>
+                  <a:srgbClr val="D64550"/>
+                </a:solidFill>
+                <a:latin typeface="Cambria"/>
+                <a:ea typeface="Cambria"/>
+                <a:cs typeface="Cambria"/>
+                <a:sym typeface="Cambria"/>
+              </a:rPr>
+              <a:t>0</a:t>
+            </a:r>
+            <a:endParaRPr b="0" i="0" sz="8200" u="none" cap="none" strike="noStrike">
+              <a:solidFill>
+                <a:schemeClr val="dk1"/>
+              </a:solidFill>
+              <a:latin typeface="Calibri"/>
+              <a:ea typeface="Calibri"/>
+              <a:cs typeface="Calibri"/>
+              <a:sym typeface="Calibri"/>
+            </a:endParaRPr>
+          </a:p>
+        </p:txBody>
+      </p:sp>
+      <p:sp>
+        <p:nvSpPr>
+          <p:cNvPr id="228" name="Google Shape;228;p13"/>
+          <p:cNvSpPr txBox="1"/>
+          <p:nvPr/>
+        </p:nvSpPr>
+        <p:spPr>
+          <a:xfrm>
+            <a:off x="640080" y="4059936"/>
+            <a:ext cx="3154680" cy="457200"/>
+          </a:xfrm>
+          <a:prstGeom prst="rect">
+            <a:avLst/>
+          </a:prstGeom>
+          <a:noFill/>
+          <a:ln>
+            <a:noFill/>
+          </a:ln>
+        </p:spPr>
+        <p:txBody>
+          <a:bodyPr anchorCtr="0" anchor="ctr" bIns="0" lIns="0" spcFirstLastPara="1" rIns="0" wrap="square" tIns="0">
+            <a:noAutofit/>
+          </a:bodyPr>
+          <a:lstStyle/>
+          <a:p>
+            <a:pPr indent="0" lvl="0" marL="0" marR="0" rtl="0" algn="ctr">
+              <a:spcBef>
+                <a:spcPts val="0"/>
+              </a:spcBef>
+              <a:spcAft>
+                <a:spcPts val="0"/>
+              </a:spcAft>
+              <a:buClr>
+                <a:srgbClr val="8DA9C4"/>
+              </a:buClr>
+              <a:buSzPts val="1400"/>
+              <a:buFont typeface="Calibri"/>
+              <a:buNone/>
+            </a:pPr>
+            <a:r>
+              <a:rPr b="0" i="0" lang="en-US" sz="1400" u="none" cap="none" strike="noStrike">
+                <a:solidFill>
+                  <a:srgbClr val="8DA9C4"/>
+                </a:solidFill>
+                <a:latin typeface="Calibri"/>
+                <a:ea typeface="Calibri"/>
+                <a:cs typeface="Calibri"/>
+                <a:sym typeface="Calibri"/>
+              </a:rPr>
+              <a:t>mejoras</a:t>
+            </a:r>
+            <a:endParaRPr b="0" i="0" sz="1400" u="none" cap="none" strike="noStrike">
+              <a:solidFill>
+                <a:schemeClr val="dk1"/>
+              </a:solidFill>
+              <a:latin typeface="Calibri"/>
+              <a:ea typeface="Calibri"/>
+              <a:cs typeface="Calibri"/>
+              <a:sym typeface="Calibri"/>
+            </a:endParaRPr>
+          </a:p>
+          <a:p>
+            <a:pPr indent="0" lvl="0" marL="0" marR="0" rtl="0" algn="ctr">
+              <a:spcBef>
+                <a:spcPts val="0"/>
+              </a:spcBef>
+              <a:spcAft>
+                <a:spcPts val="0"/>
+              </a:spcAft>
+              <a:buClr>
+                <a:srgbClr val="8DA9C4"/>
+              </a:buClr>
+              <a:buSzPts val="1400"/>
+              <a:buFont typeface="Calibri"/>
+              <a:buNone/>
+            </a:pPr>
+            <a:r>
+              <a:rPr b="0" i="0" lang="en-US" sz="1400" u="none" cap="none" strike="noStrike">
+                <a:solidFill>
+                  <a:srgbClr val="8DA9C4"/>
+                </a:solidFill>
+                <a:latin typeface="Calibri"/>
+                <a:ea typeface="Calibri"/>
+                <a:cs typeface="Calibri"/>
+                <a:sym typeface="Calibri"/>
+              </a:rPr>
+              <a:t>significativas</a:t>
+            </a:r>
+            <a:endParaRPr b="0" i="0" sz="1400" u="none" cap="none" strike="noStrike">
+              <a:solidFill>
+                <a:schemeClr val="dk1"/>
+              </a:solidFill>
+              <a:latin typeface="Calibri"/>
+              <a:ea typeface="Calibri"/>
+              <a:cs typeface="Calibri"/>
+              <a:sym typeface="Calibri"/>
+            </a:endParaRPr>
+          </a:p>
+        </p:txBody>
+      </p:sp>
+      <p:sp>
+        <p:nvSpPr>
+          <p:cNvPr id="229" name="Google Shape;229;p13"/>
+          <p:cNvSpPr txBox="1"/>
+          <p:nvPr/>
+        </p:nvSpPr>
+        <p:spPr>
+          <a:xfrm>
+            <a:off x="640080" y="4562856"/>
+            <a:ext cx="3154680" cy="960120"/>
+          </a:xfrm>
+          <a:prstGeom prst="rect">
+            <a:avLst/>
+          </a:prstGeom>
+          <a:noFill/>
+          <a:ln>
+            <a:noFill/>
+          </a:ln>
+        </p:spPr>
+        <p:txBody>
+          <a:bodyPr anchorCtr="0" anchor="ctr" bIns="0" lIns="0" spcFirstLastPara="1" rIns="0" wrap="square" tIns="0">
+            <a:noAutofit/>
+          </a:bodyPr>
+          <a:lstStyle/>
+          <a:p>
+            <a:pPr indent="0" lvl="0" marL="0" marR="0" rtl="0" algn="ctr">
+              <a:spcBef>
+                <a:spcPts val="0"/>
+              </a:spcBef>
+              <a:spcAft>
+                <a:spcPts val="0"/>
+              </a:spcAft>
+              <a:buClr>
+                <a:srgbClr val="F2A0A6"/>
+              </a:buClr>
+              <a:buSzPts val="8200"/>
+              <a:buFont typeface="Cambria"/>
+              <a:buNone/>
+            </a:pPr>
+            <a:r>
+              <a:rPr b="1" i="0" lang="en-US" sz="8200" u="none" cap="none" strike="noStrike">
+                <a:solidFill>
+                  <a:srgbClr val="F2A0A6"/>
+                </a:solidFill>
+                <a:latin typeface="Cambria"/>
+                <a:ea typeface="Cambria"/>
+                <a:cs typeface="Cambria"/>
+                <a:sym typeface="Cambria"/>
+              </a:rPr>
+              <a:t>6</a:t>
+            </a:r>
+            <a:endParaRPr b="0" i="0" sz="8200" u="none" cap="none" strike="noStrike">
+              <a:solidFill>
+                <a:schemeClr val="dk1"/>
+              </a:solidFill>
+              <a:latin typeface="Calibri"/>
+              <a:ea typeface="Calibri"/>
+              <a:cs typeface="Calibri"/>
+              <a:sym typeface="Calibri"/>
+            </a:endParaRPr>
+          </a:p>
+        </p:txBody>
+      </p:sp>
+      <p:sp>
+        <p:nvSpPr>
+          <p:cNvPr id="230" name="Google Shape;230;p13"/>
+          <p:cNvSpPr txBox="1"/>
+          <p:nvPr/>
+        </p:nvSpPr>
+        <p:spPr>
+          <a:xfrm>
+            <a:off x="640080" y="5495544"/>
+            <a:ext cx="3154680" cy="457200"/>
+          </a:xfrm>
+          <a:prstGeom prst="rect">
+            <a:avLst/>
+          </a:prstGeom>
+          <a:noFill/>
+          <a:ln>
+            <a:noFill/>
+          </a:ln>
+        </p:spPr>
+        <p:txBody>
+          <a:bodyPr anchorCtr="0" anchor="ctr" bIns="0" lIns="0" spcFirstLastPara="1" rIns="0" wrap="square" tIns="0">
+            <a:noAutofit/>
+          </a:bodyPr>
+          <a:lstStyle/>
+          <a:p>
+            <a:pPr indent="0" lvl="0" marL="0" marR="0" rtl="0" algn="ctr">
+              <a:spcBef>
+                <a:spcPts val="0"/>
+              </a:spcBef>
+              <a:spcAft>
+                <a:spcPts val="0"/>
+              </a:spcAft>
+              <a:buClr>
+                <a:srgbClr val="8DA9C4"/>
+              </a:buClr>
+              <a:buSzPts val="1400"/>
+              <a:buFont typeface="Calibri"/>
+              <a:buNone/>
+            </a:pPr>
+            <a:r>
+              <a:rPr b="0" i="0" lang="en-US" sz="1400" u="none" cap="none" strike="noStrike">
+                <a:solidFill>
+                  <a:srgbClr val="8DA9C4"/>
+                </a:solidFill>
+                <a:latin typeface="Calibri"/>
+                <a:ea typeface="Calibri"/>
+                <a:cs typeface="Calibri"/>
+                <a:sym typeface="Calibri"/>
+              </a:rPr>
+              <a:t>degradaciones</a:t>
+            </a:r>
+            <a:endParaRPr b="0" i="0" sz="1400" u="none" cap="none" strike="noStrike">
+              <a:solidFill>
+                <a:schemeClr val="dk1"/>
+              </a:solidFill>
+              <a:latin typeface="Calibri"/>
+              <a:ea typeface="Calibri"/>
+              <a:cs typeface="Calibri"/>
+              <a:sym typeface="Calibri"/>
+            </a:endParaRPr>
+          </a:p>
+          <a:p>
+            <a:pPr indent="0" lvl="0" marL="0" marR="0" rtl="0" algn="ctr">
+              <a:spcBef>
+                <a:spcPts val="0"/>
+              </a:spcBef>
+              <a:spcAft>
+                <a:spcPts val="0"/>
+              </a:spcAft>
+              <a:buClr>
+                <a:srgbClr val="8DA9C4"/>
+              </a:buClr>
+              <a:buSzPts val="1400"/>
+              <a:buFont typeface="Calibri"/>
+              <a:buNone/>
+            </a:pPr>
+            <a:r>
+              <a:rPr b="0" i="0" lang="en-US" sz="1400" u="none" cap="none" strike="noStrike">
+                <a:solidFill>
+                  <a:srgbClr val="8DA9C4"/>
+                </a:solidFill>
+                <a:latin typeface="Calibri"/>
+                <a:ea typeface="Calibri"/>
+                <a:cs typeface="Calibri"/>
+                <a:sym typeface="Calibri"/>
+              </a:rPr>
+              <a:t>significativas (p &lt; 0,05)</a:t>
+            </a:r>
+            <a:endParaRPr b="0" i="0" sz="1400" u="none" cap="none" strike="noStrike">
+              <a:solidFill>
+                <a:schemeClr val="dk1"/>
+              </a:solidFill>
+              <a:latin typeface="Calibri"/>
+              <a:ea typeface="Calibri"/>
+              <a:cs typeface="Calibri"/>
+              <a:sym typeface="Calibri"/>
+            </a:endParaRPr>
+          </a:p>
+        </p:txBody>
+      </p:sp>
+      <p:sp>
+        <p:nvSpPr>
+          <p:cNvPr id="232" name="Google Shape;232;p13"/>
+          <p:cNvSpPr txBox="1"/>
+          <p:nvPr/>
+        </p:nvSpPr>
+        <p:spPr>
+          <a:xfrm>
+            <a:off x="640080" y="5907024"/>
+            <a:ext cx="10908792" cy="347472"/>
+          </a:xfrm>
+          <a:prstGeom prst="rect">
+            <a:avLst/>
+          </a:prstGeom>
+          <a:noFill/>
+          <a:ln>
+            <a:noFill/>
+          </a:ln>
+        </p:spPr>
+        <p:txBody>
+          <a:bodyPr anchorCtr="0" anchor="ctr" bIns="0" lIns="0" spcFirstLastPara="1" rIns="0" wrap="square" tIns="0">
+            <a:noAutofit/>
+          </a:bodyPr>
+          <a:lstStyle/>
+          <a:p>
+            <a:pPr indent="0" lvl="0" marL="0" marR="0" rtl="0" algn="l">
+              <a:spcBef>
+                <a:spcPts val="0"/>
+              </a:spcBef>
+              <a:spcAft>
+                <a:spcPts val="0"/>
+              </a:spcAft>
+              <a:buClr>
+                <a:srgbClr val="8DA9C4"/>
+              </a:buClr>
+              <a:buSzPts val="1250"/>
+              <a:buFont typeface="Calibri"/>
+              <a:buNone/>
+            </a:pPr>
+            <a:r>
+              <a:rPr b="0" i="0" lang="en-US" sz="1250" u="none" cap="none" strike="noStrike">
+                <a:solidFill>
+                  <a:srgbClr val="8DA9C4"/>
+                </a:solidFill>
+                <a:latin typeface="Calibri"/>
+                <a:ea typeface="Calibri"/>
+                <a:cs typeface="Calibri"/>
+                <a:sym typeface="Calibri"/>
+              </a:rPr>
+              <a:t xml:space="preserve">Cuando la barra de dispersión cruza el cero, la subida no se distingue del ruido de la propia inicialización. Las cuatro la cruzan.</a:t>
+            </a:r>
           </a:p>
         </p:txBody>
       </p:sp>
@@ -11748,6 +10822,595 @@
 </p:sld>
 </file>
 
+<file path=ppt/slides/slide15.xml><?xml version="1.0" encoding="utf-8"?>
+<p:sld xmlns:a="http://schemas.openxmlformats.org/drawingml/2006/main" xmlns:r="http://schemas.openxmlformats.org/officeDocument/2006/relationships" xmlns:mc="http://schemas.openxmlformats.org/markup-compatibility/2006" xmlns:mv="urn:schemas-microsoft-com:mac:vml" xmlns:p="http://schemas.openxmlformats.org/presentationml/2006/main" xmlns:c="http://schemas.openxmlformats.org/drawingml/2006/chart" xmlns:dgm="http://schemas.openxmlformats.org/drawingml/2006/diagram" xmlns:o="urn:schemas-microsoft-com:office:office" xmlns:v="urn:schemas-microsoft-com:vml" xmlns:pvml="urn:schemas-microsoft-com:office:powerpoint" xmlns:com="http://schemas.openxmlformats.org/drawingml/2006/compatibility" xmlns:p14="http://schemas.microsoft.com/office/powerpoint/2010/main" xmlns:p15="http://schemas.microsoft.com/office/powerpoint/2012/main" xmlns:ahyp="http://schemas.microsoft.com/office/drawing/2018/hyperlinkcolor">
+  <p:cSld>
+    <p:spTree>
+      <p:nvGrpSpPr>
+        <p:cNvPr id="240" name="Shape 240"/>
+        <p:cNvGrpSpPr/>
+        <p:nvPr/>
+      </p:nvGrpSpPr>
+      <p:grpSpPr>
+        <a:xfrm>
+          <a:off x="0" y="0"/>
+          <a:ext cx="0" cy="0"/>
+          <a:chOff x="0" y="0"/>
+          <a:chExt cx="0" cy="0"/>
+        </a:xfrm>
+      </p:grpSpPr>
+      <p:sp>
+        <p:nvSpPr>
+          <p:cNvPr id="241" name="Google Shape;241;p14"/>
+          <p:cNvSpPr txBox="1"/>
+          <p:nvPr/>
+        </p:nvSpPr>
+        <p:spPr>
+          <a:xfrm>
+            <a:off x="640080" y="457200"/>
+            <a:ext cx="7315200" cy="320040"/>
+          </a:xfrm>
+          <a:prstGeom prst="rect">
+            <a:avLst/>
+          </a:prstGeom>
+          <a:noFill/>
+          <a:ln>
+            <a:noFill/>
+          </a:ln>
+        </p:spPr>
+        <p:txBody>
+          <a:bodyPr anchorCtr="0" anchor="ctr" bIns="0" lIns="0" spcFirstLastPara="1" rIns="0" wrap="square" tIns="0">
+            <a:noAutofit/>
+          </a:bodyPr>
+          <a:lstStyle/>
+          <a:p>
+            <a:pPr indent="0" lvl="0" marL="0" marR="0" rtl="0" algn="l">
+              <a:spcBef>
+                <a:spcPts val="0"/>
+              </a:spcBef>
+              <a:spcAft>
+                <a:spcPts val="0"/>
+              </a:spcAft>
+              <a:buClr>
+                <a:srgbClr val="D64550"/>
+              </a:buClr>
+              <a:buSzPts val="1300"/>
+              <a:buFont typeface="Calibri"/>
+              <a:buNone/>
+            </a:pPr>
+            <a:r>
+              <a:rPr b="1" i="0" lang="en-US" sz="1300" u="none" cap="none" strike="noStrike">
+                <a:solidFill>
+                  <a:srgbClr val="D64550"/>
+                </a:solidFill>
+                <a:latin typeface="Calibri"/>
+                <a:ea typeface="Calibri"/>
+                <a:cs typeface="Calibri"/>
+                <a:sym typeface="Calibri"/>
+              </a:rPr>
+              <a:t xml:space="preserve">EL ENTRENAMIENTO</a:t>
+            </a:r>
+          </a:p>
+        </p:txBody>
+      </p:sp>
+      <p:sp>
+        <p:nvSpPr>
+          <p:cNvPr id="242" name="Google Shape;242;p14"/>
+          <p:cNvSpPr txBox="1"/>
+          <p:nvPr/>
+        </p:nvSpPr>
+        <p:spPr>
+          <a:xfrm>
+            <a:off x="640080" y="749808"/>
+            <a:ext cx="10881360" cy="822960"/>
+          </a:xfrm>
+          <a:prstGeom prst="rect">
+            <a:avLst/>
+          </a:prstGeom>
+          <a:noFill/>
+          <a:ln>
+            <a:noFill/>
+          </a:ln>
+        </p:spPr>
+        <p:txBody>
+          <a:bodyPr anchorCtr="0" anchor="ctr" bIns="0" lIns="0" spcFirstLastPara="1" rIns="0" wrap="square" tIns="0">
+            <a:noAutofit/>
+          </a:bodyPr>
+          <a:lstStyle/>
+          <a:p>
+            <a:pPr indent="0" lvl="0" marL="0" marR="0" rtl="0" algn="l">
+              <a:spcBef>
+                <a:spcPts val="0"/>
+              </a:spcBef>
+              <a:spcAft>
+                <a:spcPts val="0"/>
+              </a:spcAft>
+              <a:buClr>
+                <a:srgbClr val="13253A"/>
+              </a:buClr>
+              <a:buSzPts val="3200"/>
+              <a:buFont typeface="Cambria"/>
+              <a:buNone/>
+            </a:pPr>
+            <a:r>
+              <a:rPr b="1" i="0" lang="en-US" sz="3200" u="none" cap="none" strike="noStrike">
+                <a:solidFill>
+                  <a:srgbClr val="13253A"/>
+                </a:solidFill>
+                <a:latin typeface="Cambria"/>
+                <a:ea typeface="Cambria"/>
+                <a:cs typeface="Cambria"/>
+                <a:sym typeface="Cambria"/>
+              </a:rPr>
+              <a:t xml:space="preserve">Los tres generadores convergen, y uno obligó a cambiar la formulación</a:t>
+            </a:r>
+          </a:p>
+        </p:txBody>
+      </p:sp>
+      <p:pic>
+        <p:nvPicPr>
+          <p:cNvPr descr="presentacion_convergencia.png" id="243" name="Google Shape;243;p14"/>
+          <p:cNvPicPr preferRelativeResize="0"/>
+          <p:nvPr/>
+        </p:nvPicPr>
+        <p:blipFill rotWithShape="1">
+          <a:blip r:embed="rId3">
+            <a:alphaModFix/>
+          </a:blip>
+          <a:srcRect b="0" l="0" r="0" t="0"/>
+          <a:stretch/>
+        </p:blipFill>
+        <p:spPr>
+          <a:xfrm>
+            <a:off x="640080" y="1645920"/>
+            <a:ext cx="10908792" cy="3136392"/>
+          </a:xfrm>
+          <a:prstGeom prst="rect">
+            <a:avLst/>
+          </a:prstGeom>
+          <a:noFill/>
+          <a:ln>
+            <a:noFill/>
+          </a:ln>
+        </p:spPr>
+      </p:pic>
+      <p:sp>
+        <p:nvSpPr>
+          <p:cNvPr id="244" name="Google Shape;244;p14"/>
+          <p:cNvSpPr/>
+          <p:nvPr/>
+        </p:nvSpPr>
+        <p:spPr>
+          <a:xfrm>
+            <a:off x="640080" y="4983480"/>
+            <a:ext cx="5257800" cy="1353312"/>
+          </a:xfrm>
+          <a:prstGeom prst="roundRect">
+            <a:avLst>
+              <a:gd fmla="val 2778" name="adj"/>
+            </a:avLst>
+          </a:prstGeom>
+          <a:solidFill>
+            <a:srgbClr val="0B2545"/>
+          </a:solidFill>
+          <a:ln>
+            <a:noFill/>
+          </a:ln>
+        </p:spPr>
+        <p:txBody>
+          <a:bodyPr anchorCtr="0" anchor="ctr" bIns="91425" lIns="91425" spcFirstLastPara="1" rIns="91425" wrap="square" tIns="91425">
+            <a:noAutofit/>
+          </a:bodyPr>
+          <a:lstStyle/>
+          <a:p>
+            <a:pPr indent="0" lvl="0" marL="0" rtl="0" algn="l">
+              <a:spcBef>
+                <a:spcPts val="0"/>
+              </a:spcBef>
+              <a:spcAft>
+                <a:spcPts val="0"/>
+              </a:spcAft>
+              <a:buNone/>
+            </a:pPr>
+            <a:r>
+              <a:t/>
+            </a:r>
+            <a:endParaRPr/>
+          </a:p>
+        </p:txBody>
+      </p:sp>
+      <p:sp>
+        <p:nvSpPr>
+          <p:cNvPr id="245" name="Google Shape;245;p14"/>
+          <p:cNvSpPr txBox="1"/>
+          <p:nvPr/>
+        </p:nvSpPr>
+        <p:spPr>
+          <a:xfrm>
+            <a:off x="914400" y="5138928"/>
+            <a:ext cx="4709160" cy="274320"/>
+          </a:xfrm>
+          <a:prstGeom prst="rect">
+            <a:avLst/>
+          </a:prstGeom>
+          <a:noFill/>
+          <a:ln>
+            <a:noFill/>
+          </a:ln>
+        </p:spPr>
+        <p:txBody>
+          <a:bodyPr anchorCtr="0" anchor="ctr" bIns="0" lIns="0" spcFirstLastPara="1" rIns="0" wrap="square" tIns="0">
+            <a:noAutofit/>
+          </a:bodyPr>
+          <a:lstStyle/>
+          <a:p>
+            <a:pPr indent="0" lvl="0" marL="0" marR="0" rtl="0" algn="l">
+              <a:spcBef>
+                <a:spcPts val="0"/>
+              </a:spcBef>
+              <a:spcAft>
+                <a:spcPts val="0"/>
+              </a:spcAft>
+              <a:buClr>
+                <a:srgbClr val="8DA9C4"/>
+              </a:buClr>
+              <a:buSzPts val="1300"/>
+              <a:buFont typeface="Calibri"/>
+              <a:buNone/>
+            </a:pPr>
+            <a:r>
+              <a:rPr b="1" i="0" lang="en-US" sz="1300" u="none" cap="none" strike="noStrike">
+                <a:solidFill>
+                  <a:srgbClr val="8DA9C4"/>
+                </a:solidFill>
+                <a:latin typeface="Calibri"/>
+                <a:ea typeface="Calibri"/>
+                <a:cs typeface="Calibri"/>
+                <a:sym typeface="Calibri"/>
+              </a:rPr>
+              <a:t xml:space="preserve">El criterio no es el mismo para los tres</a:t>
+            </a:r>
+          </a:p>
+        </p:txBody>
+      </p:sp>
+      <p:sp>
+        <p:nvSpPr>
+          <p:cNvPr id="246" name="Google Shape;246;p14"/>
+          <p:cNvSpPr txBox="1"/>
+          <p:nvPr/>
+        </p:nvSpPr>
+        <p:spPr>
+          <a:xfrm>
+            <a:off x="914400" y="5486400"/>
+            <a:ext cx="4709160" cy="731520"/>
+          </a:xfrm>
+          <a:prstGeom prst="rect">
+            <a:avLst/>
+          </a:prstGeom>
+          <a:noFill/>
+          <a:ln>
+            <a:noFill/>
+          </a:ln>
+        </p:spPr>
+        <p:txBody>
+          <a:bodyPr anchorCtr="0" anchor="t" bIns="0" lIns="0" spcFirstLastPara="1" rIns="0" wrap="square" tIns="0">
+            <a:noAutofit/>
+          </a:bodyPr>
+          <a:lstStyle/>
+          <a:p>
+            <a:pPr indent="0" lvl="0" marL="0" marR="0" rtl="0" algn="l">
+              <a:lnSpc>
+                <a:spcPct val="125000"/>
+              </a:lnSpc>
+              <a:spcBef>
+                <a:spcPts val="0"/>
+              </a:spcBef>
+              <a:spcAft>
+                <a:spcPts val="0"/>
+              </a:spcAft>
+              <a:buClr>
+                <a:srgbClr val="FFFFFF"/>
+              </a:buClr>
+              <a:buSzPts val="1250"/>
+              <a:buFont typeface="Calibri"/>
+              <a:buNone/>
+            </a:pPr>
+            <a:r>
+              <a:rPr b="0" i="0" lang="en-US" sz="1250" u="none" cap="none" strike="noStrike">
+                <a:solidFill>
+                  <a:srgbClr val="FFFFFF"/>
+                </a:solidFill>
+                <a:latin typeface="Calibri"/>
+                <a:ea typeface="Calibri"/>
+                <a:cs typeface="Calibri"/>
+                <a:sym typeface="Calibri"/>
+              </a:rPr>
+              <a:t xml:space="preserve">En el cGAN la pérdida no baja: converge cuando el discriminador acierta 0,447, junto al 0,50 que significa que ya no distingue. En el CVAE y la difusión sí baja, y basta con que se aplane.</a:t>
+            </a:r>
+          </a:p>
+        </p:txBody>
+      </p:sp>
+      <p:sp>
+        <p:nvSpPr>
+          <p:cNvPr id="247" name="Google Shape;247;p14"/>
+          <p:cNvSpPr txBox="1"/>
+          <p:nvPr/>
+        </p:nvSpPr>
+        <p:spPr>
+          <a:xfrm>
+            <a:off x="457200" y="6473952"/>
+            <a:ext cx="7315200" cy="274320"/>
+          </a:xfrm>
+          <a:prstGeom prst="rect">
+            <a:avLst/>
+          </a:prstGeom>
+          <a:noFill/>
+          <a:ln>
+            <a:noFill/>
+          </a:ln>
+        </p:spPr>
+        <p:txBody>
+          <a:bodyPr anchorCtr="0" anchor="ctr" bIns="0" lIns="0" spcFirstLastPara="1" rIns="0" wrap="square" tIns="0">
+            <a:noAutofit/>
+          </a:bodyPr>
+          <a:lstStyle/>
+          <a:p>
+            <a:pPr indent="0" lvl="0" marL="0" marR="0" rtl="0" algn="l">
+              <a:spcBef>
+                <a:spcPts val="0"/>
+              </a:spcBef>
+              <a:spcAft>
+                <a:spcPts val="0"/>
+              </a:spcAft>
+              <a:buClr>
+                <a:srgbClr val="5B7089"/>
+              </a:buClr>
+              <a:buSzPts val="900"/>
+              <a:buFont typeface="Calibri"/>
+              <a:buNone/>
+            </a:pPr>
+            <a:r>
+              <a:rPr b="0" i="0" lang="en-US" sz="900" u="none" cap="none" strike="noStrike">
+                <a:solidFill>
+                  <a:srgbClr val="5B7089"/>
+                </a:solidFill>
+                <a:latin typeface="Calibri"/>
+                <a:ea typeface="Calibri"/>
+                <a:cs typeface="Calibri"/>
+                <a:sym typeface="Calibri"/>
+              </a:rPr>
+              <a:t>Generación de datos financieros sintéticos  ·  Taller B5-T1</a:t>
+            </a:r>
+            <a:endParaRPr b="0" i="0" sz="900" u="none" cap="none" strike="noStrike">
+              <a:solidFill>
+                <a:schemeClr val="dk1"/>
+              </a:solidFill>
+              <a:latin typeface="Calibri"/>
+              <a:ea typeface="Calibri"/>
+              <a:cs typeface="Calibri"/>
+              <a:sym typeface="Calibri"/>
+            </a:endParaRPr>
+          </a:p>
+        </p:txBody>
+      </p:sp>
+      <p:sp>
+        <p:nvSpPr>
+          <p:cNvPr id="248" name="Google Shape;248;p14"/>
+          <p:cNvSpPr txBox="1"/>
+          <p:nvPr/>
+        </p:nvSpPr>
+        <p:spPr>
+          <a:xfrm>
+            <a:off x="11277295" y="6473952"/>
+            <a:ext cx="457200" cy="274320"/>
+          </a:xfrm>
+          <a:prstGeom prst="rect">
+            <a:avLst/>
+          </a:prstGeom>
+          <a:noFill/>
+          <a:ln>
+            <a:noFill/>
+          </a:ln>
+        </p:spPr>
+        <p:txBody>
+          <a:bodyPr anchorCtr="0" anchor="ctr" bIns="0" lIns="0" spcFirstLastPara="1" rIns="0" wrap="square" tIns="0">
+            <a:noAutofit/>
+          </a:bodyPr>
+          <a:lstStyle/>
+          <a:p>
+            <a:pPr indent="0" lvl="0" marL="0" marR="0" rtl="0" algn="r">
+              <a:spcBef>
+                <a:spcPts val="0"/>
+              </a:spcBef>
+              <a:spcAft>
+                <a:spcPts val="0"/>
+              </a:spcAft>
+              <a:buClr>
+                <a:srgbClr val="5B7089"/>
+              </a:buClr>
+              <a:buSzPts val="900"/>
+              <a:buFont typeface="Calibri"/>
+              <a:buNone/>
+            </a:pPr>
+            <a:r>
+              <a:rPr b="0" i="0" lang="en-US" sz="900" u="none" cap="none" strike="noStrike">
+                <a:solidFill>
+                  <a:srgbClr val="5B7089"/>
+                </a:solidFill>
+                <a:latin typeface="Calibri"/>
+                <a:ea typeface="Calibri"/>
+                <a:cs typeface="Calibri"/>
+                <a:sym typeface="Calibri"/>
+              </a:rPr>
+              <a:t xml:space="preserve">8</a:t>
+            </a:r>
+          </a:p>
+        </p:txBody>
+      </p:sp>
+      <p:sp>
+        <p:nvSpPr>
+          <p:cNvPr id="300" name="Google Shape;300;pX"/>
+          <p:cNvSpPr/>
+          <p:nvPr/>
+        </p:nvSpPr>
+        <p:spPr>
+          <a:xfrm>
+            <a:off x="6291072" y="4983480"/>
+            <a:ext cx="5257800" cy="1353312"/>
+          </a:xfrm>
+          <a:prstGeom prst="roundRect">
+            <a:avLst>
+              <a:gd fmla="val 2778" name="adj"/>
+            </a:avLst>
+          </a:prstGeom>
+          <a:solidFill>
+            <a:srgbClr val="0B2545"/>
+          </a:solidFill>
+          <a:ln>
+            <a:noFill/>
+          </a:ln>
+        </p:spPr>
+        <p:txBody>
+          <a:bodyPr anchorCtr="0" anchor="ctr" bIns="91425" lIns="91425" spcFirstLastPara="1" rIns="91425" wrap="square" tIns="91425">
+            <a:noAutofit/>
+          </a:bodyPr>
+          <a:lstStyle/>
+          <a:p>
+            <a:pPr indent="0" lvl="0" marL="0" rtl="0" algn="l">
+              <a:spcBef>
+                <a:spcPts val="0"/>
+              </a:spcBef>
+              <a:spcAft>
+                <a:spcPts val="0"/>
+              </a:spcAft>
+              <a:buNone/>
+            </a:pPr>
+            <a:r>
+              <a:t/>
+            </a:r>
+            <a:endParaRPr/>
+          </a:p>
+        </p:txBody>
+      </p:sp>
+      <p:sp>
+        <p:nvSpPr>
+          <p:cNvPr id="301" name="Google Shape;301;pX"/>
+          <p:cNvSpPr txBox="1"/>
+          <p:nvPr/>
+        </p:nvSpPr>
+        <p:spPr>
+          <a:xfrm>
+            <a:off x="6565392" y="5138928"/>
+            <a:ext cx="4709160" cy="274320"/>
+          </a:xfrm>
+          <a:prstGeom prst="rect">
+            <a:avLst/>
+          </a:prstGeom>
+          <a:noFill/>
+          <a:ln>
+            <a:noFill/>
+          </a:ln>
+        </p:spPr>
+        <p:txBody>
+          <a:bodyPr anchorCtr="0" anchor="ctr" bIns="0" lIns="0" spcFirstLastPara="1" rIns="0" wrap="square" tIns="0">
+            <a:noAutofit/>
+          </a:bodyPr>
+          <a:lstStyle/>
+          <a:p>
+            <a:pPr indent="0" lvl="0" marL="0" marR="0" rtl="0" algn="l">
+              <a:spcBef>
+                <a:spcPts val="0"/>
+              </a:spcBef>
+              <a:spcAft>
+                <a:spcPts val="0"/>
+              </a:spcAft>
+              <a:buClr>
+                <a:srgbClr val="8DA9C4"/>
+              </a:buClr>
+              <a:buSzPts val="1300"/>
+              <a:buFont typeface="Calibri"/>
+              <a:buNone/>
+            </a:pPr>
+            <a:r>
+              <a:rPr b="1" i="0" lang="en-US" sz="1300" u="none" cap="none" strike="noStrike">
+                <a:solidFill>
+                  <a:srgbClr val="8DA9C4"/>
+                </a:solidFill>
+                <a:latin typeface="Calibri"/>
+                <a:ea typeface="Calibri"/>
+                <a:cs typeface="Calibri"/>
+                <a:sym typeface="Calibri"/>
+              </a:rPr>
+              <a:t xml:space="preserve">La formulación clásica no converge</a:t>
+            </a:r>
+          </a:p>
+        </p:txBody>
+      </p:sp>
+      <p:sp>
+        <p:nvSpPr>
+          <p:cNvPr id="302" name="Google Shape;302;pX"/>
+          <p:cNvSpPr txBox="1"/>
+          <p:nvPr/>
+        </p:nvSpPr>
+        <p:spPr>
+          <a:xfrm>
+            <a:off x="6565392" y="5486400"/>
+            <a:ext cx="4709160" cy="731520"/>
+          </a:xfrm>
+          <a:prstGeom prst="rect">
+            <a:avLst/>
+          </a:prstGeom>
+          <a:noFill/>
+          <a:ln>
+            <a:noFill/>
+          </a:ln>
+        </p:spPr>
+        <p:txBody>
+          <a:bodyPr anchorCtr="0" anchor="t" bIns="0" lIns="0" spcFirstLastPara="1" rIns="0" wrap="square" tIns="0">
+            <a:noAutofit/>
+          </a:bodyPr>
+          <a:lstStyle/>
+          <a:p>
+            <a:pPr indent="0" lvl="0" marL="0" marR="0" rtl="0" algn="l">
+              <a:lnSpc>
+                <a:spcPct val="125000"/>
+              </a:lnSpc>
+              <a:spcBef>
+                <a:spcPts val="0"/>
+              </a:spcBef>
+              <a:spcAft>
+                <a:spcPts val="0"/>
+              </a:spcAft>
+              <a:buClr>
+                <a:srgbClr val="FFFFFF"/>
+              </a:buClr>
+              <a:buSzPts val="1250"/>
+              <a:buFont typeface="Calibri"/>
+              <a:buNone/>
+            </a:pPr>
+            <a:r>
+              <a:rPr b="0" i="0" lang="en-US" sz="1250" u="none" cap="none" strike="noStrike">
+                <a:solidFill>
+                  <a:srgbClr val="FFFFFF"/>
+                </a:solidFill>
+                <a:latin typeface="Calibri"/>
+                <a:ea typeface="Calibri"/>
+                <a:cs typeface="Calibri"/>
+                <a:sym typeface="Calibri"/>
+              </a:rPr>
+              <a:t xml:space="preserve">Estimando el ruido añadido, el error se estancaba en 0,80 sobre un máximo de 1,00 y el muestreo divergía. Estimando la ventana limpia baja a 0,338.</a:t>
+            </a:r>
+          </a:p>
+        </p:txBody>
+      </p:sp>
+    </p:spTree>
+  </p:cSld>
+  <p:clrMapOvr>
+    <a:masterClrMapping/>
+  </p:clrMapOvr>
+</p:sld>
+</file>
+
 <file path=ppt/slides/slide2.xml><?xml version="1.0" encoding="utf-8"?>
 <p:sld xmlns:a="http://schemas.openxmlformats.org/drawingml/2006/main" xmlns:r="http://schemas.openxmlformats.org/officeDocument/2006/relationships" xmlns:mc="http://schemas.openxmlformats.org/markup-compatibility/2006" xmlns:mv="urn:schemas-microsoft-com:mac:vml" xmlns:p="http://schemas.openxmlformats.org/presentationml/2006/main" xmlns:c="http://schemas.openxmlformats.org/drawingml/2006/chart" xmlns:dgm="http://schemas.openxmlformats.org/drawingml/2006/diagram" xmlns:o="urn:schemas-microsoft-com:office:office" xmlns:v="urn:schemas-microsoft-com:vml" xmlns:pvml="urn:schemas-microsoft-com:office:powerpoint" xmlns:com="http://schemas.openxmlformats.org/drawingml/2006/compatibility" xmlns:p14="http://schemas.microsoft.com/office/powerpoint/2010/main" xmlns:p15="http://schemas.microsoft.com/office/powerpoint/2012/main" xmlns:ahyp="http://schemas.microsoft.com/office/drawing/2018/hyperlinkcolor">
   <p:cSld>
@@ -19258,17 +18921,8 @@
                 <a:cs typeface="Cambria"/>
                 <a:sym typeface="Cambria"/>
               </a:rPr>
-              <a:t>Cuatro generadores, todos condicionales por clase</a:t>
-            </a:r>
-            <a:endParaRPr b="0" i="0" sz="3200" u="none" cap="none" strike="noStrike">
-              <a:solidFill>
-                <a:schemeClr val="dk1"/>
-              </a:solidFill>
-              <a:latin typeface="Calibri"/>
-              <a:ea typeface="Calibri"/>
-              <a:cs typeface="Calibri"/>
-              <a:sym typeface="Calibri"/>
-            </a:endParaRPr>
+              <a:t xml:space="preserve">Tres paradigmas distintos, más una referencia mínima</a:t>
+            </a:r>
           </a:p>
         </p:txBody>
       </p:sp>
@@ -20676,8 +20330,8 @@
         </p:nvSpPr>
         <p:spPr>
           <a:xfrm>
-            <a:off x="640080" y="5257800"/>
-            <a:ext cx="10881360" cy="548640"/>
+            <a:off x="640080" y="5138928"/>
+            <a:ext cx="10881360" cy="1234440"/>
           </a:xfrm>
           <a:prstGeom prst="rect">
             <a:avLst/>
@@ -20717,17 +20371,8 @@
                 <a:cs typeface="Calibri"/>
                 <a:sym typeface="Calibri"/>
               </a:rPr>
-              <a:t>Cada uno genera 12.000 muestras y se evalúa con el mismo barrido de proporciones {0, 0,25, 0,5, 1, 2, 4}</a:t>
-            </a:r>
-            <a:endParaRPr b="0" i="0" sz="1250" u="none" cap="none" strike="noStrike">
-              <a:solidFill>
-                <a:schemeClr val="dk1"/>
-              </a:solidFill>
-              <a:latin typeface="Calibri"/>
-              <a:ea typeface="Calibri"/>
-              <a:cs typeface="Calibri"/>
-              <a:sym typeface="Calibri"/>
-            </a:endParaRPr>
+              <a:t xml:space="preserve">No son tres variantes de la misma idea: cubren las tres formas de estimar la distribución. Densidad implícita en el cGAN, que nunca la escribe y aprende del gradiente del discriminador; densidad explícita aproximada en el CVAE, que la modela con una variable latente; y basado en score en la difusión, que aprende a deshacer una degradación conocida. Los tres son condicionales por clase, porque lo que escasea no son observaciones sino episodios de estrés, y hay que poder pedirlos. El ruido gaussiano no compite con ellos: fija el mínimo exigible.</a:t>
+            </a:r>
           </a:p>
           <a:p>
             <a:pPr indent="0" lvl="0" marL="0" marR="0" rtl="0" algn="l">
@@ -20754,17 +20399,8 @@
                 <a:cs typeface="Calibri"/>
                 <a:sym typeface="Calibri"/>
               </a:rPr>
-              <a:t>sobre el presupuesto real, repitiendo cada configuración con 5 semillas.</a:t>
-            </a:r>
-            <a:endParaRPr b="0" i="0" sz="1250" u="none" cap="none" strike="noStrike">
-              <a:solidFill>
-                <a:schemeClr val="dk1"/>
-              </a:solidFill>
-              <a:latin typeface="Calibri"/>
-              <a:ea typeface="Calibri"/>
-              <a:cs typeface="Calibri"/>
-              <a:sym typeface="Calibri"/>
-            </a:endParaRPr>
+              <a:t xml:space="preserve">Cada uno genera 12.000 muestras y se evalúa con el mismo barrido de proporciones {0, 0,25, 0,5, 1, 2, 4} sobre el presupuesto real, con 5 semillas por configuración.</a:t>
+            </a:r>
           </a:p>
         </p:txBody>
       </p:sp>
@@ -22172,7 +21808,7 @@
                 <a:cs typeface="Calibri"/>
                 <a:sym typeface="Calibri"/>
               </a:rPr>
-              <a:t>8</a:t>
+              <a:t>9</a:t>
             </a:r>
             <a:endParaRPr b="0" i="0" sz="900" u="none" cap="none" strike="noStrike">
               <a:solidFill>
@@ -22739,7 +22375,7 @@
                 <a:cs typeface="Calibri"/>
                 <a:sym typeface="Calibri"/>
               </a:rPr>
-              <a:t>9</a:t>
+              <a:t>10</a:t>
             </a:r>
             <a:endParaRPr b="0" i="0" sz="900" u="none" cap="none" strike="noStrike">
               <a:solidFill>

</xml_diff>